<commit_message>
Repair canonical v1.2 PowerPoint compatibility and layout
</commit_message>
<xml_diff>
--- a/presentations/ecosystem-positioning/Ecosystem_Positioning_Architecture_Implementation_Canonical_v1.2.pptx
+++ b/presentations/ecosystem-positioning/Ecosystem_Positioning_Architecture_Implementation_Canonical_v1.2.pptx
@@ -67,20 +67,21 @@
             <a:noAutofit/>
           </a:bodyPr>
           <a:p>
-            <a:r>
-              <a:rPr b="0" lang="en-US" sz="1800" spc="-1" strike="noStrike">
-                <a:solidFill>
-                  <a:schemeClr val="dk1"/>
-                </a:solidFill>
-                <a:latin typeface="Calibri"/>
+            <a:pPr algn="ctr"/>
+            <a:r>
+              <a:rPr b="0" lang="en-US" sz="4400" spc="-1" strike="noStrike">
+                <a:solidFill>
+                  <a:srgbClr val="000000"/>
+                </a:solidFill>
+                <a:latin typeface="Arial"/>
               </a:rPr>
               <a:t>Click to move the slide</a:t>
             </a:r>
-            <a:endParaRPr b="0" lang="en-US" sz="1800" spc="-1" strike="noStrike">
-              <a:solidFill>
-                <a:schemeClr val="dk1"/>
-              </a:solidFill>
-              <a:latin typeface="Calibri"/>
+            <a:endParaRPr b="0" lang="en-US" sz="4400" spc="-1" strike="noStrike">
+              <a:solidFill>
+                <a:srgbClr val="000000"/>
+              </a:solidFill>
+              <a:latin typeface="Arial"/>
             </a:endParaRPr>
           </a:p>
         </p:txBody>
@@ -345,7 +346,7 @@
             <a:pPr indent="0" algn="r">
               <a:buNone/>
             </a:pPr>
-            <a:fld id="{037F2683-EDCB-4A5C-B20C-365364571ECA}" type="slidenum">
+            <a:fld id="{669FEE93-8B14-43DF-BA43-9BF7DEEB9FE3}" type="slidenum">
               <a:rPr b="0" lang="en-US" sz="1400" spc="-1" strike="noStrike">
                 <a:solidFill>
                   <a:srgbClr val="000000"/>
@@ -480,7 +481,7 @@
             <a:pPr indent="0">
               <a:buNone/>
             </a:pPr>
-            <a:endParaRPr b="0" lang="en-US" sz="1800" spc="-1" strike="noStrike">
+            <a:endParaRPr b="0" lang="en-US" sz="1400" spc="-1" strike="noStrike">
               <a:solidFill>
                 <a:srgbClr val="000000"/>
               </a:solidFill>
@@ -605,7 +606,7 @@
             <a:pPr indent="0">
               <a:buNone/>
             </a:pPr>
-            <a:endParaRPr b="0" lang="en-US" sz="1800" spc="-1" strike="noStrike">
+            <a:endParaRPr b="0" lang="en-US" sz="1400" spc="-1" strike="noStrike">
               <a:solidFill>
                 <a:srgbClr val="000000"/>
               </a:solidFill>
@@ -730,7 +731,7 @@
             <a:pPr indent="0">
               <a:buNone/>
             </a:pPr>
-            <a:endParaRPr b="0" lang="en-US" sz="1800" spc="-1" strike="noStrike">
+            <a:endParaRPr b="0" lang="en-US" sz="1400" spc="-1" strike="noStrike">
               <a:solidFill>
                 <a:srgbClr val="000000"/>
               </a:solidFill>
@@ -855,7 +856,7 @@
             <a:pPr indent="0">
               <a:buNone/>
             </a:pPr>
-            <a:endParaRPr b="0" lang="en-US" sz="1800" spc="-1" strike="noStrike">
+            <a:endParaRPr b="0" lang="en-US" sz="1400" spc="-1" strike="noStrike">
               <a:solidFill>
                 <a:srgbClr val="000000"/>
               </a:solidFill>
@@ -980,7 +981,7 @@
             <a:pPr indent="0">
               <a:buNone/>
             </a:pPr>
-            <a:endParaRPr b="0" lang="en-US" sz="1800" spc="-1" strike="noStrike">
+            <a:endParaRPr b="0" lang="en-US" sz="1400" spc="-1" strike="noStrike">
               <a:solidFill>
                 <a:srgbClr val="000000"/>
               </a:solidFill>
@@ -1105,7 +1106,7 @@
             <a:pPr indent="0">
               <a:buNone/>
             </a:pPr>
-            <a:endParaRPr b="0" lang="en-US" sz="1800" spc="-1" strike="noStrike">
+            <a:endParaRPr b="0" lang="en-US" sz="1400" spc="-1" strike="noStrike">
               <a:solidFill>
                 <a:srgbClr val="000000"/>
               </a:solidFill>
@@ -1230,7 +1231,7 @@
             <a:pPr indent="0">
               <a:buNone/>
             </a:pPr>
-            <a:endParaRPr b="0" lang="en-US" sz="1800" spc="-1" strike="noStrike">
+            <a:endParaRPr b="0" lang="en-US" sz="1400" spc="-1" strike="noStrike">
               <a:solidFill>
                 <a:srgbClr val="000000"/>
               </a:solidFill>
@@ -1297,7 +1298,7 @@
         <p:txBody>
           <a:bodyPr/>
           <a:p>
-            <a:fld id="{3AB314F9-617E-4402-9F39-373E5C7364FD}" type="slidenum">
+            <a:fld id="{90308ABA-E4CB-47F4-8B2D-0DDCD4D42392}" type="slidenum">
               <a:t>&lt;#&gt;</a:t>
             </a:fld>
           </a:p>
@@ -1360,23 +1361,23 @@
             <a:noAutofit/>
           </a:bodyPr>
           <a:p>
-            <a:pPr indent="0">
+            <a:pPr indent="0" algn="ctr">
               <a:buNone/>
             </a:pPr>
             <a:r>
-              <a:rPr b="0" lang="en-US" sz="1800" spc="-1" strike="noStrike">
-                <a:solidFill>
-                  <a:schemeClr val="dk1"/>
-                </a:solidFill>
-                <a:latin typeface="Calibri"/>
+              <a:rPr b="0" lang="en-US" sz="4400" spc="-1" strike="noStrike">
+                <a:solidFill>
+                  <a:srgbClr val="000000"/>
+                </a:solidFill>
+                <a:latin typeface="Arial"/>
               </a:rPr>
               <a:t>Click to edit the title text format</a:t>
             </a:r>
-            <a:endParaRPr b="0" lang="en-US" sz="1800" spc="-1" strike="noStrike">
-              <a:solidFill>
-                <a:schemeClr val="dk1"/>
-              </a:solidFill>
-              <a:latin typeface="Calibri"/>
+            <a:endParaRPr b="0" lang="en-US" sz="4400" spc="-1" strike="noStrike">
+              <a:solidFill>
+                <a:srgbClr val="000000"/>
+              </a:solidFill>
+              <a:latin typeface="Arial"/>
             </a:endParaRPr>
           </a:p>
         </p:txBody>
@@ -1423,17 +1424,17 @@
             <a:r>
               <a:rPr b="0" lang="en-US" sz="3200" spc="-1" strike="noStrike">
                 <a:solidFill>
-                  <a:schemeClr val="dk1"/>
-                </a:solidFill>
-                <a:latin typeface="Calibri"/>
+                  <a:srgbClr val="000000"/>
+                </a:solidFill>
+                <a:latin typeface="Arial"/>
               </a:rPr>
               <a:t>Click to edit the outline text format</a:t>
             </a:r>
             <a:endParaRPr b="0" lang="en-US" sz="3200" spc="-1" strike="noStrike">
               <a:solidFill>
-                <a:schemeClr val="dk1"/>
-              </a:solidFill>
-              <a:latin typeface="Calibri"/>
+                <a:srgbClr val="000000"/>
+              </a:solidFill>
+              <a:latin typeface="Arial"/>
             </a:endParaRPr>
           </a:p>
           <a:p>
@@ -1449,19 +1450,19 @@
               <a:buChar char=""/>
             </a:pPr>
             <a:r>
-              <a:rPr b="0" lang="en-US" sz="2400" spc="-1" strike="noStrike">
-                <a:solidFill>
-                  <a:schemeClr val="dk1"/>
-                </a:solidFill>
-                <a:latin typeface="Calibri"/>
+              <a:rPr b="0" lang="en-US" sz="2800" spc="-1" strike="noStrike">
+                <a:solidFill>
+                  <a:srgbClr val="000000"/>
+                </a:solidFill>
+                <a:latin typeface="Arial"/>
               </a:rPr>
               <a:t>Second Outline Level</a:t>
             </a:r>
-            <a:endParaRPr b="0" lang="en-US" sz="2400" spc="-1" strike="noStrike">
-              <a:solidFill>
-                <a:schemeClr val="dk1"/>
-              </a:solidFill>
-              <a:latin typeface="Calibri"/>
+            <a:endParaRPr b="0" lang="en-US" sz="2800" spc="-1" strike="noStrike">
+              <a:solidFill>
+                <a:srgbClr val="000000"/>
+              </a:solidFill>
+              <a:latin typeface="Arial"/>
             </a:endParaRPr>
           </a:p>
           <a:p>
@@ -1477,19 +1478,19 @@
               <a:buChar char=""/>
             </a:pPr>
             <a:r>
-              <a:rPr b="0" lang="en-US" sz="2000" spc="-1" strike="noStrike">
-                <a:solidFill>
-                  <a:schemeClr val="dk1"/>
-                </a:solidFill>
-                <a:latin typeface="Calibri"/>
+              <a:rPr b="0" lang="en-US" sz="2400" spc="-1" strike="noStrike">
+                <a:solidFill>
+                  <a:srgbClr val="000000"/>
+                </a:solidFill>
+                <a:latin typeface="Arial"/>
               </a:rPr>
               <a:t>Third Outline Level</a:t>
             </a:r>
-            <a:endParaRPr b="0" lang="en-US" sz="2000" spc="-1" strike="noStrike">
-              <a:solidFill>
-                <a:schemeClr val="dk1"/>
-              </a:solidFill>
-              <a:latin typeface="Calibri"/>
+            <a:endParaRPr b="0" lang="en-US" sz="2400" spc="-1" strike="noStrike">
+              <a:solidFill>
+                <a:srgbClr val="000000"/>
+              </a:solidFill>
+              <a:latin typeface="Arial"/>
             </a:endParaRPr>
           </a:p>
           <a:p>
@@ -1507,17 +1508,17 @@
             <a:r>
               <a:rPr b="0" lang="en-US" sz="2000" spc="-1" strike="noStrike">
                 <a:solidFill>
-                  <a:schemeClr val="dk1"/>
-                </a:solidFill>
-                <a:latin typeface="Calibri"/>
+                  <a:srgbClr val="000000"/>
+                </a:solidFill>
+                <a:latin typeface="Arial"/>
               </a:rPr>
               <a:t>Fourth Outline Level</a:t>
             </a:r>
             <a:endParaRPr b="0" lang="en-US" sz="2000" spc="-1" strike="noStrike">
               <a:solidFill>
-                <a:schemeClr val="dk1"/>
-              </a:solidFill>
-              <a:latin typeface="Calibri"/>
+                <a:srgbClr val="000000"/>
+              </a:solidFill>
+              <a:latin typeface="Arial"/>
             </a:endParaRPr>
           </a:p>
           <a:p>
@@ -1535,17 +1536,17 @@
             <a:r>
               <a:rPr b="0" lang="en-US" sz="2000" spc="-1" strike="noStrike">
                 <a:solidFill>
-                  <a:schemeClr val="dk1"/>
-                </a:solidFill>
-                <a:latin typeface="Calibri"/>
+                  <a:srgbClr val="000000"/>
+                </a:solidFill>
+                <a:latin typeface="Arial"/>
               </a:rPr>
               <a:t>Fifth Outline Level</a:t>
             </a:r>
             <a:endParaRPr b="0" lang="en-US" sz="2000" spc="-1" strike="noStrike">
               <a:solidFill>
-                <a:schemeClr val="dk1"/>
-              </a:solidFill>
-              <a:latin typeface="Calibri"/>
+                <a:srgbClr val="000000"/>
+              </a:solidFill>
+              <a:latin typeface="Arial"/>
             </a:endParaRPr>
           </a:p>
           <a:p>
@@ -1563,17 +1564,17 @@
             <a:r>
               <a:rPr b="0" lang="en-US" sz="2000" spc="-1" strike="noStrike">
                 <a:solidFill>
-                  <a:schemeClr val="dk1"/>
-                </a:solidFill>
-                <a:latin typeface="Calibri"/>
+                  <a:srgbClr val="000000"/>
+                </a:solidFill>
+                <a:latin typeface="Arial"/>
               </a:rPr>
               <a:t>Sixth Outline Level</a:t>
             </a:r>
             <a:endParaRPr b="0" lang="en-US" sz="2000" spc="-1" strike="noStrike">
               <a:solidFill>
-                <a:schemeClr val="dk1"/>
-              </a:solidFill>
-              <a:latin typeface="Calibri"/>
+                <a:srgbClr val="000000"/>
+              </a:solidFill>
+              <a:latin typeface="Arial"/>
             </a:endParaRPr>
           </a:p>
           <a:p>
@@ -1591,17 +1592,17 @@
             <a:r>
               <a:rPr b="0" lang="en-US" sz="2000" spc="-1" strike="noStrike">
                 <a:solidFill>
-                  <a:schemeClr val="dk1"/>
-                </a:solidFill>
-                <a:latin typeface="Calibri"/>
+                  <a:srgbClr val="000000"/>
+                </a:solidFill>
+                <a:latin typeface="Arial"/>
               </a:rPr>
               <a:t>Seventh Outline Level</a:t>
             </a:r>
             <a:endParaRPr b="0" lang="en-US" sz="2000" spc="-1" strike="noStrike">
               <a:solidFill>
-                <a:schemeClr val="dk1"/>
-              </a:solidFill>
-              <a:latin typeface="Calibri"/>
+                <a:srgbClr val="000000"/>
+              </a:solidFill>
+              <a:latin typeface="Arial"/>
             </a:endParaRPr>
           </a:p>
         </p:txBody>
@@ -1774,7 +1775,7 @@
         <p:spPr>
           <a:xfrm>
             <a:off x="567000" y="6546960"/>
-            <a:ext cx="3245760" cy="164160"/>
+            <a:ext cx="3245400" cy="163800"/>
           </a:xfrm>
           <a:prstGeom prst="rect">
             <a:avLst/>
@@ -1822,7 +1823,7 @@
         <p:spPr>
           <a:xfrm>
             <a:off x="4187880" y="6546960"/>
-            <a:ext cx="3382920" cy="164160"/>
+            <a:ext cx="3382560" cy="163800"/>
           </a:xfrm>
           <a:prstGeom prst="rect">
             <a:avLst/>
@@ -1883,7 +1884,7 @@
         <p:spPr>
           <a:xfrm>
             <a:off x="11064240" y="6537960"/>
-            <a:ext cx="502560" cy="164160"/>
+            <a:ext cx="502200" cy="163800"/>
           </a:xfrm>
           <a:prstGeom prst="rect">
             <a:avLst/>
@@ -1903,6 +1904,9 @@
                 <a:spcPct val="100000"/>
               </a:lnSpc>
               <a:buNone/>
+              <a:tabLst>
+                <a:tab algn="l" pos="0"/>
+              </a:tabLst>
               <a:defRPr b="1" lang="en-US" sz="750" spc="-1" strike="noStrike">
                 <a:solidFill>
                   <a:srgbClr val="1b273f"/>
@@ -1918,8 +1922,11 @@
                 <a:spcPct val="100000"/>
               </a:lnSpc>
               <a:buNone/>
-            </a:pPr>
-            <a:fld id="{6AEDD9E5-9E0F-4F00-A1AE-965FE7471B5D}" type="slidenum">
+              <a:tabLst>
+                <a:tab algn="l" pos="0"/>
+              </a:tabLst>
+            </a:pPr>
+            <a:fld id="{1CD36860-E741-462D-93F3-B78FE671E5F3}" type="slidenum">
               <a:rPr b="1" lang="en-US" sz="750" spc="-1" strike="noStrike">
                 <a:solidFill>
                   <a:srgbClr val="1b273f"/>
@@ -1966,23 +1973,23 @@
             <a:noAutofit/>
           </a:bodyPr>
           <a:p>
-            <a:pPr indent="0">
+            <a:pPr indent="0" algn="ctr">
               <a:buNone/>
             </a:pPr>
             <a:r>
-              <a:rPr b="0" lang="en-US" sz="1800" spc="-1" strike="noStrike">
-                <a:solidFill>
-                  <a:schemeClr val="dk1"/>
-                </a:solidFill>
-                <a:latin typeface="Calibri"/>
+              <a:rPr b="0" lang="en-US" sz="4400" spc="-1" strike="noStrike">
+                <a:solidFill>
+                  <a:srgbClr val="000000"/>
+                </a:solidFill>
+                <a:latin typeface="Arial"/>
               </a:rPr>
               <a:t>Click to edit the title text format</a:t>
             </a:r>
-            <a:endParaRPr b="0" lang="en-US" sz="1800" spc="-1" strike="noStrike">
-              <a:solidFill>
-                <a:schemeClr val="dk1"/>
-              </a:solidFill>
-              <a:latin typeface="Calibri"/>
+            <a:endParaRPr b="0" lang="en-US" sz="4400" spc="-1" strike="noStrike">
+              <a:solidFill>
+                <a:srgbClr val="000000"/>
+              </a:solidFill>
+              <a:latin typeface="Arial"/>
             </a:endParaRPr>
           </a:p>
         </p:txBody>
@@ -2029,17 +2036,17 @@
             <a:r>
               <a:rPr b="0" lang="en-US" sz="3200" spc="-1" strike="noStrike">
                 <a:solidFill>
-                  <a:schemeClr val="dk1"/>
-                </a:solidFill>
-                <a:latin typeface="Calibri"/>
+                  <a:srgbClr val="000000"/>
+                </a:solidFill>
+                <a:latin typeface="Arial"/>
               </a:rPr>
               <a:t>Click to edit the outline text format</a:t>
             </a:r>
             <a:endParaRPr b="0" lang="en-US" sz="3200" spc="-1" strike="noStrike">
               <a:solidFill>
-                <a:schemeClr val="dk1"/>
-              </a:solidFill>
-              <a:latin typeface="Calibri"/>
+                <a:srgbClr val="000000"/>
+              </a:solidFill>
+              <a:latin typeface="Arial"/>
             </a:endParaRPr>
           </a:p>
           <a:p>
@@ -2055,19 +2062,19 @@
               <a:buChar char=""/>
             </a:pPr>
             <a:r>
-              <a:rPr b="0" lang="en-US" sz="2400" spc="-1" strike="noStrike">
-                <a:solidFill>
-                  <a:schemeClr val="dk1"/>
-                </a:solidFill>
-                <a:latin typeface="Calibri"/>
+              <a:rPr b="0" lang="en-US" sz="2800" spc="-1" strike="noStrike">
+                <a:solidFill>
+                  <a:srgbClr val="000000"/>
+                </a:solidFill>
+                <a:latin typeface="Arial"/>
               </a:rPr>
               <a:t>Second Outline Level</a:t>
             </a:r>
-            <a:endParaRPr b="0" lang="en-US" sz="2400" spc="-1" strike="noStrike">
-              <a:solidFill>
-                <a:schemeClr val="dk1"/>
-              </a:solidFill>
-              <a:latin typeface="Calibri"/>
+            <a:endParaRPr b="0" lang="en-US" sz="2800" spc="-1" strike="noStrike">
+              <a:solidFill>
+                <a:srgbClr val="000000"/>
+              </a:solidFill>
+              <a:latin typeface="Arial"/>
             </a:endParaRPr>
           </a:p>
           <a:p>
@@ -2083,19 +2090,19 @@
               <a:buChar char=""/>
             </a:pPr>
             <a:r>
-              <a:rPr b="0" lang="en-US" sz="2000" spc="-1" strike="noStrike">
-                <a:solidFill>
-                  <a:schemeClr val="dk1"/>
-                </a:solidFill>
-                <a:latin typeface="Calibri"/>
+              <a:rPr b="0" lang="en-US" sz="2400" spc="-1" strike="noStrike">
+                <a:solidFill>
+                  <a:srgbClr val="000000"/>
+                </a:solidFill>
+                <a:latin typeface="Arial"/>
               </a:rPr>
               <a:t>Third Outline Level</a:t>
             </a:r>
-            <a:endParaRPr b="0" lang="en-US" sz="2000" spc="-1" strike="noStrike">
-              <a:solidFill>
-                <a:schemeClr val="dk1"/>
-              </a:solidFill>
-              <a:latin typeface="Calibri"/>
+            <a:endParaRPr b="0" lang="en-US" sz="2400" spc="-1" strike="noStrike">
+              <a:solidFill>
+                <a:srgbClr val="000000"/>
+              </a:solidFill>
+              <a:latin typeface="Arial"/>
             </a:endParaRPr>
           </a:p>
           <a:p>
@@ -2113,17 +2120,17 @@
             <a:r>
               <a:rPr b="0" lang="en-US" sz="2000" spc="-1" strike="noStrike">
                 <a:solidFill>
-                  <a:schemeClr val="dk1"/>
-                </a:solidFill>
-                <a:latin typeface="Calibri"/>
+                  <a:srgbClr val="000000"/>
+                </a:solidFill>
+                <a:latin typeface="Arial"/>
               </a:rPr>
               <a:t>Fourth Outline Level</a:t>
             </a:r>
             <a:endParaRPr b="0" lang="en-US" sz="2000" spc="-1" strike="noStrike">
               <a:solidFill>
-                <a:schemeClr val="dk1"/>
-              </a:solidFill>
-              <a:latin typeface="Calibri"/>
+                <a:srgbClr val="000000"/>
+              </a:solidFill>
+              <a:latin typeface="Arial"/>
             </a:endParaRPr>
           </a:p>
           <a:p>
@@ -2141,17 +2148,17 @@
             <a:r>
               <a:rPr b="0" lang="en-US" sz="2000" spc="-1" strike="noStrike">
                 <a:solidFill>
-                  <a:schemeClr val="dk1"/>
-                </a:solidFill>
-                <a:latin typeface="Calibri"/>
+                  <a:srgbClr val="000000"/>
+                </a:solidFill>
+                <a:latin typeface="Arial"/>
               </a:rPr>
               <a:t>Fifth Outline Level</a:t>
             </a:r>
             <a:endParaRPr b="0" lang="en-US" sz="2000" spc="-1" strike="noStrike">
               <a:solidFill>
-                <a:schemeClr val="dk1"/>
-              </a:solidFill>
-              <a:latin typeface="Calibri"/>
+                <a:srgbClr val="000000"/>
+              </a:solidFill>
+              <a:latin typeface="Arial"/>
             </a:endParaRPr>
           </a:p>
           <a:p>
@@ -2169,17 +2176,17 @@
             <a:r>
               <a:rPr b="0" lang="en-US" sz="2000" spc="-1" strike="noStrike">
                 <a:solidFill>
-                  <a:schemeClr val="dk1"/>
-                </a:solidFill>
-                <a:latin typeface="Calibri"/>
+                  <a:srgbClr val="000000"/>
+                </a:solidFill>
+                <a:latin typeface="Arial"/>
               </a:rPr>
               <a:t>Sixth Outline Level</a:t>
             </a:r>
             <a:endParaRPr b="0" lang="en-US" sz="2000" spc="-1" strike="noStrike">
               <a:solidFill>
-                <a:schemeClr val="dk1"/>
-              </a:solidFill>
-              <a:latin typeface="Calibri"/>
+                <a:srgbClr val="000000"/>
+              </a:solidFill>
+              <a:latin typeface="Arial"/>
             </a:endParaRPr>
           </a:p>
           <a:p>
@@ -2197,17 +2204,17 @@
             <a:r>
               <a:rPr b="0" lang="en-US" sz="2000" spc="-1" strike="noStrike">
                 <a:solidFill>
-                  <a:schemeClr val="dk1"/>
-                </a:solidFill>
-                <a:latin typeface="Calibri"/>
+                  <a:srgbClr val="000000"/>
+                </a:solidFill>
+                <a:latin typeface="Arial"/>
               </a:rPr>
               <a:t>Seventh Outline Level</a:t>
             </a:r>
             <a:endParaRPr b="0" lang="en-US" sz="2000" spc="-1" strike="noStrike">
               <a:solidFill>
-                <a:schemeClr val="dk1"/>
-              </a:solidFill>
-              <a:latin typeface="Calibri"/>
+                <a:srgbClr val="000000"/>
+              </a:solidFill>
+              <a:latin typeface="Arial"/>
             </a:endParaRPr>
           </a:p>
         </p:txBody>
@@ -2254,7 +2261,7 @@
         <p:spPr>
           <a:xfrm>
             <a:off x="9795960" y="365760"/>
-            <a:ext cx="1828440" cy="228240"/>
+            <a:ext cx="1828080" cy="227880"/>
           </a:xfrm>
           <a:prstGeom prst="rect">
             <a:avLst/>
@@ -2395,7 +2402,7 @@
         <p:spPr>
           <a:xfrm>
             <a:off x="567000" y="1783080"/>
-            <a:ext cx="7040520" cy="1333080"/>
+            <a:ext cx="7315200" cy="1335024"/>
           </a:xfrm>
           <a:prstGeom prst="rect">
             <a:avLst/>
@@ -2420,9 +2427,15 @@
               <a:lnSpc>
                 <a:spcPct val="95000"/>
               </a:lnSpc>
-            </a:pPr>
-            <a:r>
-              <a:rPr b="1" lang="en-US" sz="4600" spc="-100" strike="noStrike" u="sng">
+              <a:spcBef>
+                <a:spcPts val="0"/>
+              </a:spcBef>
+              <a:spcAft>
+                <a:spcPts val="0"/>
+              </a:spcAft>
+            </a:pPr>
+            <a:r>
+              <a:rPr b="1" lang="en-US" sz="4000" spc="-100" strike="noStrike" u="sng">
                 <a:solidFill>
                   <a:srgbClr val="0563c1"/>
                 </a:solidFill>
@@ -2445,9 +2458,15 @@
               <a:lnSpc>
                 <a:spcPct val="95000"/>
               </a:lnSpc>
-            </a:pPr>
-            <a:r>
-              <a:rPr b="1" lang="en-US" sz="4600" spc="-100" strike="noStrike" u="sng">
+              <a:spcBef>
+                <a:spcPts val="0"/>
+              </a:spcBef>
+              <a:spcAft>
+                <a:spcPts val="0"/>
+              </a:spcAft>
+            </a:pPr>
+            <a:r>
+              <a:rPr b="1" lang="en-US" sz="4000" spc="-100" strike="noStrike" u="sng">
                 <a:solidFill>
                   <a:srgbClr val="0563c1"/>
                 </a:solidFill>
@@ -2476,7 +2495,7 @@
         <p:spPr>
           <a:xfrm>
             <a:off x="567000" y="3383280"/>
-            <a:ext cx="6309000" cy="472680"/>
+            <a:ext cx="6308640" cy="472320"/>
           </a:xfrm>
           <a:prstGeom prst="rect">
             <a:avLst/>
@@ -2530,7 +2549,7 @@
         <p:spPr>
           <a:xfrm>
             <a:off x="631080" y="4928760"/>
-            <a:ext cx="292320" cy="292320"/>
+            <a:ext cx="291960" cy="291960"/>
           </a:xfrm>
           <a:prstGeom prst="ellipse">
             <a:avLst/>
@@ -2584,7 +2603,7 @@
         <p:spPr>
           <a:xfrm>
             <a:off x="2560320" y="4937760"/>
-            <a:ext cx="273960" cy="273960"/>
+            <a:ext cx="273600" cy="273600"/>
           </a:xfrm>
           <a:prstGeom prst="rect">
             <a:avLst/>
@@ -2638,7 +2657,7 @@
         <p:spPr>
           <a:xfrm>
             <a:off x="4480560" y="4937760"/>
-            <a:ext cx="273960" cy="273960"/>
+            <a:ext cx="273600" cy="273600"/>
           </a:xfrm>
           <a:prstGeom prst="rect">
             <a:avLst/>
@@ -2692,7 +2711,7 @@
         <p:spPr>
           <a:xfrm>
             <a:off x="6400800" y="4937760"/>
-            <a:ext cx="273960" cy="273960"/>
+            <a:ext cx="273600" cy="273600"/>
           </a:xfrm>
           <a:prstGeom prst="rect">
             <a:avLst/>
@@ -2893,7 +2912,7 @@
         <p:spPr>
           <a:xfrm>
             <a:off x="1188720" y="4782240"/>
-            <a:ext cx="1096920" cy="122040"/>
+            <a:ext cx="1096560" cy="121680"/>
           </a:xfrm>
           <a:prstGeom prst="rect">
             <a:avLst/>
@@ -2947,7 +2966,7 @@
         <p:spPr>
           <a:xfrm>
             <a:off x="3108960" y="4782240"/>
-            <a:ext cx="1096920" cy="122040"/>
+            <a:ext cx="1096560" cy="121680"/>
           </a:xfrm>
           <a:prstGeom prst="rect">
             <a:avLst/>
@@ -3001,7 +3020,7 @@
         <p:spPr>
           <a:xfrm>
             <a:off x="5029200" y="4782240"/>
-            <a:ext cx="1096920" cy="122040"/>
+            <a:ext cx="1096560" cy="121680"/>
           </a:xfrm>
           <a:prstGeom prst="rect">
             <a:avLst/>
@@ -3055,7 +3074,7 @@
         <p:spPr>
           <a:xfrm>
             <a:off x="137160" y="5330880"/>
-            <a:ext cx="1279800" cy="129960"/>
+            <a:ext cx="1279440" cy="129600"/>
           </a:xfrm>
           <a:prstGeom prst="rect">
             <a:avLst/>
@@ -3082,7 +3101,7 @@
               </a:lnSpc>
             </a:pPr>
             <a:r>
-              <a:rPr b="0" lang="en-US" sz="850" spc="128" strike="noStrike">
+              <a:rPr b="0" lang="en-US" sz="850" spc="126" strike="noStrike">
                 <a:solidFill>
                   <a:srgbClr val="a6abb5"/>
                 </a:solidFill>
@@ -3109,7 +3128,7 @@
         <p:spPr>
           <a:xfrm>
             <a:off x="2057400" y="5330880"/>
-            <a:ext cx="1279800" cy="129960"/>
+            <a:ext cx="1279440" cy="129600"/>
           </a:xfrm>
           <a:prstGeom prst="rect">
             <a:avLst/>
@@ -3136,7 +3155,7 @@
               </a:lnSpc>
             </a:pPr>
             <a:r>
-              <a:rPr b="0" lang="en-US" sz="850" spc="128" strike="noStrike">
+              <a:rPr b="0" lang="en-US" sz="850" spc="126" strike="noStrike">
                 <a:solidFill>
                   <a:srgbClr val="a6abb5"/>
                 </a:solidFill>
@@ -3163,7 +3182,7 @@
         <p:spPr>
           <a:xfrm>
             <a:off x="3977640" y="5330880"/>
-            <a:ext cx="1279800" cy="129960"/>
+            <a:ext cx="1279440" cy="129600"/>
           </a:xfrm>
           <a:prstGeom prst="rect">
             <a:avLst/>
@@ -3190,7 +3209,7 @@
               </a:lnSpc>
             </a:pPr>
             <a:r>
-              <a:rPr b="0" lang="en-US" sz="850" spc="128" strike="noStrike">
+              <a:rPr b="0" lang="en-US" sz="850" spc="126" strike="noStrike">
                 <a:solidFill>
                   <a:srgbClr val="a6abb5"/>
                 </a:solidFill>
@@ -3217,7 +3236,7 @@
         <p:spPr>
           <a:xfrm>
             <a:off x="5897880" y="5330880"/>
-            <a:ext cx="1279800" cy="129960"/>
+            <a:ext cx="1279440" cy="129600"/>
           </a:xfrm>
           <a:prstGeom prst="rect">
             <a:avLst/>
@@ -3244,7 +3263,7 @@
               </a:lnSpc>
             </a:pPr>
             <a:r>
-              <a:rPr b="0" lang="en-US" sz="850" spc="128" strike="noStrike">
+              <a:rPr b="0" lang="en-US" sz="850" spc="126" strike="noStrike">
                 <a:solidFill>
                   <a:srgbClr val="a6abb5"/>
                 </a:solidFill>
@@ -3271,7 +3290,7 @@
         <p:spPr>
           <a:xfrm>
             <a:off x="5440680" y="5550480"/>
-            <a:ext cx="2194200" cy="122040"/>
+            <a:ext cx="2193840" cy="121680"/>
           </a:xfrm>
           <a:prstGeom prst="rect">
             <a:avLst/>
@@ -3325,7 +3344,7 @@
         <p:spPr>
           <a:xfrm>
             <a:off x="8001000" y="1371600"/>
-            <a:ext cx="3620520" cy="3428640"/>
+            <a:ext cx="3620160" cy="3428280"/>
           </a:xfrm>
           <a:prstGeom prst="rect">
             <a:avLst/>
@@ -3381,7 +3400,7 @@
         <p:spPr>
           <a:xfrm>
             <a:off x="8001000" y="1371600"/>
-            <a:ext cx="40680" cy="3428640"/>
+            <a:ext cx="40320" cy="3428280"/>
           </a:xfrm>
           <a:prstGeom prst="rect">
             <a:avLst/>
@@ -3434,7 +3453,7 @@
         <p:spPr>
           <a:xfrm>
             <a:off x="8275320" y="1627560"/>
-            <a:ext cx="3163320" cy="137880"/>
+            <a:ext cx="3162960" cy="137520"/>
           </a:xfrm>
           <a:prstGeom prst="rect">
             <a:avLst/>
@@ -3488,7 +3507,7 @@
         <p:spPr>
           <a:xfrm>
             <a:off x="8275320" y="1938600"/>
-            <a:ext cx="3163320" cy="739080"/>
+            <a:ext cx="3162960" cy="738720"/>
           </a:xfrm>
           <a:prstGeom prst="rect">
             <a:avLst/>
@@ -3542,7 +3561,7 @@
         <p:spPr>
           <a:xfrm>
             <a:off x="8275320" y="2788920"/>
-            <a:ext cx="3071880" cy="618480"/>
+            <a:ext cx="3071520" cy="618120"/>
           </a:xfrm>
           <a:prstGeom prst="rect">
             <a:avLst/>
@@ -3642,7 +3661,7 @@
         <p:spPr>
           <a:xfrm>
             <a:off x="8275320" y="4114800"/>
-            <a:ext cx="3163320" cy="686520"/>
+            <a:ext cx="3162960" cy="686520"/>
           </a:xfrm>
           <a:prstGeom prst="rect">
             <a:avLst/>
@@ -3757,7 +3776,7 @@
         <p:spPr>
           <a:xfrm>
             <a:off x="10527480" y="6291000"/>
-            <a:ext cx="1096920" cy="273960"/>
+            <a:ext cx="1096560" cy="273600"/>
           </a:xfrm>
           <a:prstGeom prst="rect">
             <a:avLst/>
@@ -3802,7 +3821,7 @@
         <p:spPr>
           <a:xfrm>
             <a:off x="1383120" y="6510600"/>
-            <a:ext cx="1933560" cy="104040"/>
+            <a:ext cx="1933200" cy="103680"/>
           </a:xfrm>
           <a:prstGeom prst="rect">
             <a:avLst/>
@@ -3898,7 +3917,7 @@
         <p:spPr>
           <a:xfrm>
             <a:off x="567000" y="146160"/>
-            <a:ext cx="2559960" cy="253800"/>
+            <a:ext cx="2559600" cy="253800"/>
           </a:xfrm>
           <a:prstGeom prst="rect">
             <a:avLst/>
@@ -3952,7 +3971,7 @@
         <p:spPr>
           <a:xfrm>
             <a:off x="567000" y="329040"/>
-            <a:ext cx="10972440" cy="16200"/>
+            <a:ext cx="10972080" cy="15840"/>
           </a:xfrm>
           <a:prstGeom prst="rect">
             <a:avLst/>
@@ -4005,7 +4024,7 @@
         <p:spPr>
           <a:xfrm>
             <a:off x="10881360" y="146160"/>
-            <a:ext cx="639720" cy="253800"/>
+            <a:ext cx="639360" cy="253800"/>
           </a:xfrm>
           <a:prstGeom prst="rect">
             <a:avLst/>
@@ -4059,7 +4078,7 @@
         <p:spPr>
           <a:xfrm>
             <a:off x="567000" y="676800"/>
-            <a:ext cx="10789560" cy="466920"/>
+            <a:ext cx="10789200" cy="466920"/>
           </a:xfrm>
           <a:prstGeom prst="rect">
             <a:avLst/>
@@ -4113,7 +4132,7 @@
         <p:spPr>
           <a:xfrm>
             <a:off x="0" y="6336720"/>
-            <a:ext cx="12191400" cy="520920"/>
+            <a:ext cx="12191040" cy="520560"/>
           </a:xfrm>
           <a:prstGeom prst="rect">
             <a:avLst/>
@@ -4166,7 +4185,7 @@
         <p:spPr>
           <a:xfrm>
             <a:off x="567000" y="6492240"/>
-            <a:ext cx="10972440" cy="13320"/>
+            <a:ext cx="10972080" cy="12960"/>
           </a:xfrm>
           <a:prstGeom prst="rect">
             <a:avLst/>
@@ -4219,7 +4238,7 @@
         <p:spPr>
           <a:xfrm>
             <a:off x="4114800" y="6528960"/>
-            <a:ext cx="3657240" cy="205560"/>
+            <a:ext cx="3656880" cy="205560"/>
           </a:xfrm>
           <a:prstGeom prst="rect">
             <a:avLst/>
@@ -4273,7 +4292,7 @@
         <p:spPr>
           <a:xfrm>
             <a:off x="11018520" y="6528960"/>
-            <a:ext cx="365400" cy="219240"/>
+            <a:ext cx="365040" cy="219240"/>
           </a:xfrm>
           <a:prstGeom prst="rect">
             <a:avLst/>
@@ -4327,7 +4346,7 @@
         <p:spPr>
           <a:xfrm>
             <a:off x="567000" y="1134000"/>
-            <a:ext cx="10881000" cy="237240"/>
+            <a:ext cx="10880640" cy="236880"/>
           </a:xfrm>
           <a:prstGeom prst="rect">
             <a:avLst/>
@@ -4381,7 +4400,7 @@
         <p:spPr>
           <a:xfrm>
             <a:off x="9052560" y="91440"/>
-            <a:ext cx="1462680" cy="219240"/>
+            <a:ext cx="1462320" cy="218880"/>
           </a:xfrm>
           <a:prstGeom prst="roundRect">
             <a:avLst>
@@ -4439,7 +4458,7 @@
         <p:spPr>
           <a:xfrm>
             <a:off x="567000" y="1627560"/>
-            <a:ext cx="1371240" cy="868680"/>
+            <a:ext cx="1370880" cy="868680"/>
           </a:xfrm>
           <a:prstGeom prst="roundRect">
             <a:avLst>
@@ -4490,7 +4509,7 @@
               </a:rPr>
               <a:t>0 · Epistemic Awareness</a:t>
             </a:r>
-            <a:endParaRPr b="0" lang="en-US" sz="900" spc="-1" strike="noStrike">
+            <a:endParaRPr b="0" lang="en-US" sz="760" spc="-1" strike="noStrike">
               <a:solidFill>
                 <a:srgbClr val="000000"/>
               </a:solidFill>
@@ -4521,7 +4540,7 @@
               </a:rPr>
               <a:t>Local position</a:t>
             </a:r>
-            <a:endParaRPr b="0" lang="en-US" sz="900" spc="-1" strike="noStrike">
+            <a:endParaRPr b="0" lang="en-US" sz="800" spc="-1" strike="noStrike">
               <a:solidFill>
                 <a:srgbClr val="000000"/>
               </a:solidFill>
@@ -4570,7 +4589,7 @@
         <p:spPr>
           <a:xfrm>
             <a:off x="2180880" y="1627560"/>
-            <a:ext cx="1371240" cy="868680"/>
+            <a:ext cx="1370880" cy="868680"/>
           </a:xfrm>
           <a:prstGeom prst="roundRect">
             <a:avLst>
@@ -4621,7 +4640,7 @@
               </a:rPr>
               <a:t>1 · Ecosystem</a:t>
             </a:r>
-            <a:endParaRPr b="0" lang="en-US" sz="1000" spc="-1" strike="noStrike">
+            <a:endParaRPr b="0" lang="en-US" sz="800" spc="-1" strike="noStrike">
               <a:solidFill>
                 <a:srgbClr val="000000"/>
               </a:solidFill>
@@ -4652,7 +4671,7 @@
               </a:rPr>
               <a:t>Signalling</a:t>
             </a:r>
-            <a:endParaRPr b="0" lang="en-US" sz="1000" spc="-1" strike="noStrike">
+            <a:endParaRPr b="0" lang="en-US" sz="800" spc="-1" strike="noStrike">
               <a:solidFill>
                 <a:srgbClr val="000000"/>
               </a:solidFill>
@@ -4672,20 +4691,17 @@
               </a:spcAft>
             </a:pPr>
             <a:r>
-              <a:rPr b="0" lang="en-US" sz="700" spc="-1" strike="noStrike" u="sng">
-                <a:solidFill>
-                  <a:srgbClr val="0563c1"/>
-                </a:solidFill>
-                <a:uFillTx/>
-                <a:latin typeface="Aptos"/>
-                <a:ea typeface="Aptos"/>
-                <a:hlinkClick r:id="rId6"/>
+              <a:rPr sz="700" b="0" u="sng">
+                <a:solidFill>
+                  <a:schemeClr val="hlink"/>
+                </a:solidFill>
+                <a:hlinkClick r:id="rId4"/>
               </a:rPr>
               <a:t>Qualify / exchange</a:t>
             </a:r>
             <a:br/>
             <a:r>
-              <a:rPr sz="700" u="sng">
+              <a:rPr sz="700" b="0" u="sng">
                 <a:solidFill>
                   <a:schemeClr val="hlink"/>
                 </a:solidFill>
@@ -4693,7 +4709,7 @@
               </a:rPr>
               <a:t>ReceivedSignals</a:t>
             </a:r>
-            <a:endParaRPr b="0" lang="en-US" sz="750" spc="-1" strike="noStrike">
+            <a:endParaRPr b="0" lang="en-US" sz="700" spc="-1" strike="noStrike">
               <a:solidFill>
                 <a:srgbClr val="000000"/>
               </a:solidFill>
@@ -4711,7 +4727,7 @@
         <p:spPr>
           <a:xfrm>
             <a:off x="3794760" y="1627560"/>
-            <a:ext cx="1371240" cy="868680"/>
+            <a:ext cx="1370880" cy="868680"/>
           </a:xfrm>
           <a:prstGeom prst="roundRect">
             <a:avLst>
@@ -4758,11 +4774,11 @@
                 <a:uFillTx/>
                 <a:latin typeface="Aptos"/>
                 <a:ea typeface="Aptos"/>
-                <a:hlinkClick r:id="rId7"/>
+                <a:hlinkClick r:id="rId8"/>
               </a:rPr>
               <a:t>2 · Ecosystem</a:t>
             </a:r>
-            <a:endParaRPr b="0" lang="en-US" sz="900" spc="-1" strike="noStrike">
+            <a:endParaRPr b="0" lang="en-US" sz="800" spc="-1" strike="noStrike">
               <a:solidFill>
                 <a:srgbClr val="000000"/>
               </a:solidFill>
@@ -4789,11 +4805,11 @@
                 <a:uFillTx/>
                 <a:latin typeface="Aptos"/>
                 <a:ea typeface="Aptos"/>
-                <a:hlinkClick r:id="rId8"/>
+                <a:hlinkClick r:id="rId9"/>
               </a:rPr>
               <a:t>Cartography</a:t>
             </a:r>
-            <a:endParaRPr b="0" lang="en-US" sz="900" spc="-1" strike="noStrike">
+            <a:endParaRPr b="0" lang="en-US" sz="800" spc="-1" strike="noStrike">
               <a:solidFill>
                 <a:srgbClr val="000000"/>
               </a:solidFill>
@@ -4820,11 +4836,11 @@
                 <a:uFillTx/>
                 <a:latin typeface="Aptos"/>
                 <a:ea typeface="Aptos"/>
-                <a:hlinkClick r:id="rId9"/>
+                <a:hlinkClick r:id="rId10"/>
               </a:rPr>
               <a:t>Update Cart_i / Δ_Cart_i</a:t>
             </a:r>
-            <a:endParaRPr b="0" lang="en-US" sz="750" spc="-1" strike="noStrike">
+            <a:endParaRPr b="0" lang="en-US" sz="700" spc="-1" strike="noStrike">
               <a:solidFill>
                 <a:srgbClr val="000000"/>
               </a:solidFill>
@@ -4842,7 +4858,7 @@
         <p:spPr>
           <a:xfrm>
             <a:off x="5408640" y="1627560"/>
-            <a:ext cx="1371240" cy="868680"/>
+            <a:ext cx="1370880" cy="868680"/>
           </a:xfrm>
           <a:prstGeom prst="roundRect">
             <a:avLst>
@@ -4889,11 +4905,11 @@
                 <a:uFillTx/>
                 <a:latin typeface="Aptos"/>
                 <a:ea typeface="Aptos"/>
-                <a:hlinkClick r:id="rId10"/>
+                <a:hlinkClick r:id="rId11"/>
               </a:rPr>
               <a:t>3 · Regime</a:t>
             </a:r>
-            <a:endParaRPr b="0" lang="en-US" sz="1000" spc="-1" strike="noStrike">
+            <a:endParaRPr b="0" lang="en-US" sz="800" spc="-1" strike="noStrike">
               <a:solidFill>
                 <a:srgbClr val="000000"/>
               </a:solidFill>
@@ -4920,11 +4936,11 @@
                 <a:uFillTx/>
                 <a:latin typeface="Aptos"/>
                 <a:ea typeface="Aptos"/>
-                <a:hlinkClick r:id="rId11"/>
+                <a:hlinkClick r:id="rId12"/>
               </a:rPr>
               <a:t>Awareness</a:t>
             </a:r>
-            <a:endParaRPr b="0" lang="en-US" sz="1000" spc="-1" strike="noStrike">
+            <a:endParaRPr b="0" lang="en-US" sz="800" spc="-1" strike="noStrike">
               <a:solidFill>
                 <a:srgbClr val="000000"/>
               </a:solidFill>
@@ -4944,28 +4960,25 @@
               </a:spcAft>
             </a:pPr>
             <a:r>
-              <a:rPr b="0" lang="en-US" sz="700" spc="-1" strike="noStrike" u="sng">
-                <a:solidFill>
-                  <a:srgbClr val="0563c1"/>
-                </a:solidFill>
-                <a:uFillTx/>
-                <a:latin typeface="Aptos"/>
-                <a:ea typeface="Aptos"/>
-                <a:hlinkClick r:id="rId12"/>
+              <a:rPr sz="700" b="0" u="sng">
+                <a:solidFill>
+                  <a:schemeClr val="hlink"/>
+                </a:solidFill>
+                <a:hlinkClick r:id="rId11"/>
               </a:rPr>
               <a:t>Emit Δ_RA + regime</a:t>
             </a:r>
             <a:br/>
             <a:r>
-              <a:rPr sz="700" u="sng">
+              <a:rPr sz="700" b="0" u="sng">
                 <a:solidFill>
                   <a:schemeClr val="hlink"/>
                 </a:solidFill>
-                <a:hlinkClick r:id="rId10"/>
+                <a:hlinkClick r:id="rId11"/>
               </a:rPr>
               <a:t>overlay</a:t>
             </a:r>
-            <a:endParaRPr b="0" lang="en-US" sz="750" spc="-1" strike="noStrike">
+            <a:endParaRPr b="0" lang="en-US" sz="700" spc="-1" strike="noStrike">
               <a:solidFill>
                 <a:srgbClr val="000000"/>
               </a:solidFill>
@@ -4983,7 +4996,7 @@
         <p:spPr>
           <a:xfrm>
             <a:off x="7022520" y="1627560"/>
-            <a:ext cx="1371240" cy="868680"/>
+            <a:ext cx="1370880" cy="868680"/>
           </a:xfrm>
           <a:prstGeom prst="roundRect">
             <a:avLst>
@@ -5030,11 +5043,11 @@
                 <a:uFillTx/>
                 <a:latin typeface="Aptos"/>
                 <a:ea typeface="Aptos"/>
-                <a:hlinkClick r:id="rId13"/>
+                <a:hlinkClick r:id="rId15"/>
               </a:rPr>
               <a:t>4 · MSCA Operation</a:t>
             </a:r>
-            <a:endParaRPr b="0" lang="en-US" sz="1000" spc="-1" strike="noStrike">
+            <a:endParaRPr b="0" lang="en-US" sz="800" spc="-1" strike="noStrike">
               <a:solidFill>
                 <a:srgbClr val="000000"/>
               </a:solidFill>
@@ -5061,11 +5074,11 @@
                 <a:uFillTx/>
                 <a:latin typeface="Aptos"/>
                 <a:ea typeface="Aptos"/>
-                <a:hlinkClick r:id="rId14"/>
+                <a:hlinkClick r:id="rId16"/>
               </a:rPr>
               <a:t>Drift &amp; Posture</a:t>
             </a:r>
-            <a:endParaRPr b="0" lang="en-US" sz="1000" spc="-1" strike="noStrike">
+            <a:endParaRPr b="0" lang="en-US" sz="800" spc="-1" strike="noStrike">
               <a:solidFill>
                 <a:srgbClr val="000000"/>
               </a:solidFill>
@@ -5085,28 +5098,25 @@
               </a:spcAft>
             </a:pPr>
             <a:r>
-              <a:rPr b="0" lang="en-US" sz="700" spc="-1" strike="noStrike" u="sng">
-                <a:solidFill>
-                  <a:srgbClr val="0563c1"/>
-                </a:solidFill>
-                <a:uFillTx/>
-                <a:latin typeface="Aptos"/>
-                <a:ea typeface="Aptos"/>
+              <a:rPr sz="700" b="0" u="sng">
+                <a:solidFill>
+                  <a:schemeClr val="hlink"/>
+                </a:solidFill>
                 <a:hlinkClick r:id="rId15"/>
               </a:rPr>
               <a:t>Role_effective · Type 0/1/2</a:t>
             </a:r>
             <a:br/>
             <a:r>
-              <a:rPr sz="700" u="sng">
+              <a:rPr sz="700" b="0" u="sng">
                 <a:solidFill>
                   <a:schemeClr val="hlink"/>
                 </a:solidFill>
-                <a:hlinkClick r:id="rId13"/>
+                <a:hlinkClick r:id="rId15"/>
               </a:rPr>
               <a:t>· P1/P2/P3</a:t>
             </a:r>
-            <a:endParaRPr b="0" lang="en-US" sz="750" spc="-1" strike="noStrike">
+            <a:endParaRPr b="0" lang="en-US" sz="700" spc="-1" strike="noStrike">
               <a:solidFill>
                 <a:srgbClr val="000000"/>
               </a:solidFill>
@@ -5124,7 +5134,7 @@
         <p:spPr>
           <a:xfrm>
             <a:off x="8636400" y="1627560"/>
-            <a:ext cx="1371240" cy="868680"/>
+            <a:ext cx="1370880" cy="868680"/>
           </a:xfrm>
           <a:prstGeom prst="roundRect">
             <a:avLst>
@@ -5171,11 +5181,11 @@
                 <a:uFillTx/>
                 <a:latin typeface="Aptos"/>
                 <a:ea typeface="Aptos"/>
-                <a:hlinkClick r:id="rId16"/>
+                <a:hlinkClick r:id="rId19"/>
               </a:rPr>
               <a:t>5 · Gradient &amp;</a:t>
             </a:r>
-            <a:endParaRPr b="0" lang="en-US" sz="1000" spc="-1" strike="noStrike">
+            <a:endParaRPr b="0" lang="en-US" sz="800" spc="-1" strike="noStrike">
               <a:solidFill>
                 <a:srgbClr val="000000"/>
               </a:solidFill>
@@ -5202,11 +5212,11 @@
                 <a:uFillTx/>
                 <a:latin typeface="Aptos"/>
                 <a:ea typeface="Aptos"/>
-                <a:hlinkClick r:id="rId17"/>
+                <a:hlinkClick r:id="rId20"/>
               </a:rPr>
               <a:t>Repositioning</a:t>
             </a:r>
-            <a:endParaRPr b="0" lang="en-US" sz="1000" spc="-1" strike="noStrike">
+            <a:endParaRPr b="0" lang="en-US" sz="800" spc="-1" strike="noStrike">
               <a:solidFill>
                 <a:srgbClr val="000000"/>
               </a:solidFill>
@@ -5226,38 +5236,35 @@
               </a:spcAft>
             </a:pPr>
             <a:r>
-              <a:rPr b="0" lang="en-US" sz="700" spc="-1" strike="noStrike" u="sng">
-                <a:solidFill>
-                  <a:srgbClr val="0563c1"/>
-                </a:solidFill>
-                <a:uFillTx/>
-                <a:latin typeface="Aptos"/>
-                <a:ea typeface="Aptos"/>
-                <a:hlinkClick r:id="rId18"/>
+              <a:rPr sz="700" b="0" u="sng">
+                <a:solidFill>
+                  <a:schemeClr val="hlink"/>
+                </a:solidFill>
+                <a:hlinkClick r:id="rId19"/>
               </a:rPr>
               <a:t>Rank from Role_effective →</a:t>
             </a:r>
             <a:br/>
             <a:r>
-              <a:rPr sz="700" u="sng">
+              <a:rPr sz="700" b="0" u="sng">
                 <a:solidFill>
                   <a:schemeClr val="hlink"/>
                 </a:solidFill>
-                <a:hlinkClick r:id="rId16"/>
+                <a:hlinkClick r:id="rId19"/>
               </a:rPr>
               <a:t>ACC gate → re-contract /</a:t>
             </a:r>
             <a:br/>
             <a:r>
-              <a:rPr sz="700" u="sng">
+              <a:rPr sz="700" b="0" u="sng">
                 <a:solidFill>
                   <a:schemeClr val="hlink"/>
                 </a:solidFill>
-                <a:hlinkClick r:id="rId16"/>
+                <a:hlinkClick r:id="rId19"/>
               </a:rPr>
               <a:t>escalate</a:t>
             </a:r>
-            <a:endParaRPr b="0" lang="en-US" sz="750" spc="-1" strike="noStrike">
+            <a:endParaRPr b="0" lang="en-US" sz="700" spc="-1" strike="noStrike">
               <a:solidFill>
                 <a:srgbClr val="000000"/>
               </a:solidFill>
@@ -5275,7 +5282,7 @@
         <p:spPr>
           <a:xfrm>
             <a:off x="10250280" y="1627560"/>
-            <a:ext cx="1371240" cy="868680"/>
+            <a:ext cx="1370880" cy="868680"/>
           </a:xfrm>
           <a:prstGeom prst="roundRect">
             <a:avLst>
@@ -5322,11 +5329,11 @@
                 <a:uFillTx/>
                 <a:latin typeface="Aptos"/>
                 <a:ea typeface="Aptos"/>
-                <a:hlinkClick r:id="rId19"/>
+                <a:hlinkClick r:id="rId24"/>
               </a:rPr>
               <a:t>Human / Institutional</a:t>
             </a:r>
-            <a:endParaRPr b="0" lang="en-US" sz="900" spc="-1" strike="noStrike">
+            <a:endParaRPr b="0" lang="en-US" sz="800" spc="-1" strike="noStrike">
               <a:solidFill>
                 <a:srgbClr val="000000"/>
               </a:solidFill>
@@ -5353,11 +5360,11 @@
                 <a:uFillTx/>
                 <a:latin typeface="Aptos"/>
                 <a:ea typeface="Aptos"/>
-                <a:hlinkClick r:id="rId20"/>
+                <a:hlinkClick r:id="rId25"/>
               </a:rPr>
               <a:t>Governance</a:t>
             </a:r>
-            <a:endParaRPr b="0" lang="en-US" sz="900" spc="-1" strike="noStrike">
+            <a:endParaRPr b="0" lang="en-US" sz="800" spc="-1" strike="noStrike">
               <a:solidFill>
                 <a:srgbClr val="000000"/>
               </a:solidFill>
@@ -5377,24 +5384,21 @@
               </a:spcAft>
             </a:pPr>
             <a:r>
-              <a:rPr b="0" lang="en-US" sz="700" spc="-1" strike="noStrike" u="sng">
-                <a:solidFill>
-                  <a:srgbClr val="0563c1"/>
-                </a:solidFill>
-                <a:uFillTx/>
-                <a:latin typeface="Aptos"/>
-                <a:ea typeface="Aptos"/>
-                <a:hlinkClick r:id="rId21"/>
+              <a:rPr sz="700" b="0" u="sng">
+                <a:solidFill>
+                  <a:schemeClr val="hlink"/>
+                </a:solidFill>
+                <a:hlinkClick r:id="rId24"/>
               </a:rPr>
               <a:t>Authority decides;</a:t>
             </a:r>
             <a:br/>
             <a:r>
-              <a:rPr sz="700" u="sng">
+              <a:rPr sz="700" b="0" u="sng">
                 <a:solidFill>
                   <a:schemeClr val="hlink"/>
                 </a:solidFill>
-                <a:hlinkClick r:id="rId19"/>
+                <a:hlinkClick r:id="rId24"/>
               </a:rPr>
               <a:t>signals ≠ commands</a:t>
             </a:r>
@@ -5419,7 +5423,7 @@
         <p:spPr>
           <a:xfrm>
             <a:off x="1938240" y="2011680"/>
-            <a:ext cx="242640" cy="360"/>
+            <a:ext cx="243000" cy="720"/>
           </a:xfrm>
           <a:prstGeom prst="straightConnector1">
             <a:avLst/>
@@ -5445,7 +5449,7 @@
         <p:spPr>
           <a:xfrm>
             <a:off x="3552120" y="2011680"/>
-            <a:ext cx="243000" cy="360"/>
+            <a:ext cx="243360" cy="720"/>
           </a:xfrm>
           <a:prstGeom prst="straightConnector1">
             <a:avLst/>
@@ -5471,7 +5475,7 @@
         <p:spPr>
           <a:xfrm>
             <a:off x="5166360" y="2011680"/>
-            <a:ext cx="242640" cy="360"/>
+            <a:ext cx="243000" cy="720"/>
           </a:xfrm>
           <a:prstGeom prst="straightConnector1">
             <a:avLst/>
@@ -5497,7 +5501,7 @@
         <p:spPr>
           <a:xfrm>
             <a:off x="6780240" y="2011680"/>
-            <a:ext cx="242640" cy="360"/>
+            <a:ext cx="243000" cy="720"/>
           </a:xfrm>
           <a:prstGeom prst="straightConnector1">
             <a:avLst/>
@@ -5523,7 +5527,7 @@
         <p:spPr>
           <a:xfrm>
             <a:off x="8394120" y="2011680"/>
-            <a:ext cx="242640" cy="360"/>
+            <a:ext cx="243000" cy="720"/>
           </a:xfrm>
           <a:prstGeom prst="straightConnector1">
             <a:avLst/>
@@ -5549,7 +5553,7 @@
         <p:spPr>
           <a:xfrm>
             <a:off x="10008000" y="2011680"/>
-            <a:ext cx="242640" cy="360"/>
+            <a:ext cx="243000" cy="720"/>
           </a:xfrm>
           <a:prstGeom prst="straightConnector1">
             <a:avLst/>
@@ -5743,7 +5747,7 @@
         <p:spPr>
           <a:xfrm>
             <a:off x="3291840" y="1344240"/>
-            <a:ext cx="5577480" cy="182520"/>
+            <a:ext cx="5577120" cy="182160"/>
           </a:xfrm>
           <a:prstGeom prst="rect">
             <a:avLst/>
@@ -5809,7 +5813,7 @@
         <p:spPr>
           <a:xfrm>
             <a:off x="567000" y="2697480"/>
-            <a:ext cx="1846800" cy="2541600"/>
+            <a:ext cx="1846440" cy="2541240"/>
           </a:xfrm>
           <a:prstGeom prst="roundRect">
             <a:avLst>
@@ -5833,7 +5837,7 @@
           <a:fontRef idx="minor"/>
         </p:style>
         <p:txBody>
-          <a:bodyPr lIns="82440" rIns="82440" tIns="64080" anchor="t">
+          <a:bodyPr lIns="82440" rIns="82440" tIns="64080" bIns="45000" anchor="t">
             <a:noAutofit/>
           </a:bodyPr>
           <a:p>
@@ -5850,7 +5854,7 @@
                 <a:uFillTx/>
                 <a:latin typeface="Aptos"/>
                 <a:ea typeface="Aptos"/>
-                <a:hlinkClick r:id="rId22"/>
+                <a:hlinkClick r:id="rId28"/>
               </a:rPr>
               <a:t>Repositioning posture</a:t>
             </a:r>
@@ -5875,7 +5879,7 @@
                 <a:uFillTx/>
                 <a:latin typeface="Aptos"/>
                 <a:ea typeface="Aptos"/>
-                <a:hlinkClick r:id="rId23"/>
+                <a:hlinkClick r:id="rId29"/>
               </a:rPr>
               <a:t>Step 4 · P1 / P2 / P3</a:t>
             </a:r>
@@ -5897,7 +5901,7 @@
         <p:spPr>
           <a:xfrm>
             <a:off x="640080" y="3383280"/>
-            <a:ext cx="1700280" cy="566640"/>
+            <a:ext cx="1699920" cy="566280"/>
           </a:xfrm>
           <a:prstGeom prst="roundRect">
             <a:avLst>
@@ -5984,7 +5988,7 @@
         <p:spPr>
           <a:xfrm>
             <a:off x="640080" y="3986640"/>
-            <a:ext cx="1700280" cy="566640"/>
+            <a:ext cx="1699920" cy="566280"/>
           </a:xfrm>
           <a:prstGeom prst="roundRect">
             <a:avLst>
@@ -6071,7 +6075,7 @@
         <p:spPr>
           <a:xfrm>
             <a:off x="640080" y="4590360"/>
-            <a:ext cx="1700280" cy="566640"/>
+            <a:ext cx="1699920" cy="566280"/>
           </a:xfrm>
           <a:prstGeom prst="roundRect">
             <a:avLst>
@@ -6158,7 +6162,7 @@
         <p:spPr>
           <a:xfrm>
             <a:off x="2532960" y="2697480"/>
-            <a:ext cx="2788560" cy="2541600"/>
+            <a:ext cx="2788200" cy="2541240"/>
           </a:xfrm>
           <a:prstGeom prst="roundRect">
             <a:avLst>
@@ -6182,7 +6186,7 @@
           <a:fontRef idx="minor"/>
         </p:style>
         <p:txBody>
-          <a:bodyPr lIns="82440" rIns="82440" tIns="64080" anchor="t">
+          <a:bodyPr lIns="82440" rIns="82440" tIns="64080" bIns="45000" anchor="t">
             <a:noAutofit/>
           </a:bodyPr>
           <a:p>
@@ -6199,7 +6203,7 @@
                 <a:uFillTx/>
                 <a:latin typeface="Aptos"/>
                 <a:ea typeface="Aptos"/>
-                <a:hlinkClick r:id="rId24"/>
+                <a:hlinkClick r:id="rId30"/>
               </a:rPr>
               <a:t>Epistemic state — 4 components</a:t>
             </a:r>
@@ -6224,7 +6228,7 @@
                 <a:uFillTx/>
                 <a:latin typeface="Aptos"/>
                 <a:ea typeface="Aptos"/>
-                <a:hlinkClick r:id="rId25"/>
+                <a:hlinkClick r:id="rId31"/>
               </a:rPr>
               <a:t>Step 0 · A/B/C/D, relative to the active decision window</a:t>
             </a:r>
@@ -6246,7 +6250,7 @@
         <p:spPr>
           <a:xfrm>
             <a:off x="2615040" y="5038200"/>
-            <a:ext cx="2624040" cy="145800"/>
+            <a:ext cx="2623680" cy="145440"/>
           </a:xfrm>
           <a:prstGeom prst="rect">
             <a:avLst/>
@@ -6300,7 +6304,7 @@
         <p:spPr>
           <a:xfrm>
             <a:off x="2624400" y="3383280"/>
-            <a:ext cx="1252440" cy="785880"/>
+            <a:ext cx="1252080" cy="785520"/>
           </a:xfrm>
           <a:prstGeom prst="roundRect">
             <a:avLst>
@@ -6387,7 +6391,7 @@
         <p:spPr>
           <a:xfrm>
             <a:off x="3977640" y="3383280"/>
-            <a:ext cx="1252440" cy="785880"/>
+            <a:ext cx="1252080" cy="785520"/>
           </a:xfrm>
           <a:prstGeom prst="roundRect">
             <a:avLst>
@@ -6474,7 +6478,7 @@
         <p:spPr>
           <a:xfrm>
             <a:off x="2624400" y="4215240"/>
-            <a:ext cx="1252440" cy="785880"/>
+            <a:ext cx="1252080" cy="785520"/>
           </a:xfrm>
           <a:prstGeom prst="roundRect">
             <a:avLst>
@@ -6561,7 +6565,7 @@
         <p:spPr>
           <a:xfrm>
             <a:off x="3977640" y="4215240"/>
-            <a:ext cx="1252440" cy="785880"/>
+            <a:ext cx="1252080" cy="785520"/>
           </a:xfrm>
           <a:prstGeom prst="roundRect">
             <a:avLst>
@@ -6648,7 +6652,7 @@
         <p:spPr>
           <a:xfrm>
             <a:off x="5459040" y="2697480"/>
-            <a:ext cx="1828440" cy="2541600"/>
+            <a:ext cx="1828080" cy="2541240"/>
           </a:xfrm>
           <a:prstGeom prst="roundRect">
             <a:avLst>
@@ -6672,7 +6676,7 @@
           <a:fontRef idx="minor"/>
         </p:style>
         <p:txBody>
-          <a:bodyPr lIns="82440" rIns="82440" tIns="64080" anchor="t">
+          <a:bodyPr lIns="82440" rIns="82440" tIns="64080" bIns="45000" anchor="t">
             <a:noAutofit/>
           </a:bodyPr>
           <a:p>
@@ -6689,7 +6693,7 @@
                 <a:uFillTx/>
                 <a:latin typeface="Aptos"/>
                 <a:ea typeface="Aptos"/>
-                <a:hlinkClick r:id="rId26"/>
+                <a:hlinkClick r:id="rId32"/>
               </a:rPr>
               <a:t>Ecosystem Signalling / EHD</a:t>
             </a:r>
@@ -6714,7 +6718,7 @@
                 <a:uFillTx/>
                 <a:latin typeface="Aptos"/>
                 <a:ea typeface="Aptos"/>
-                <a:hlinkClick r:id="rId27"/>
+                <a:hlinkClick r:id="rId33"/>
               </a:rPr>
               <a:t>Step 1 · what crosses a boundary</a:t>
             </a:r>
@@ -6736,7 +6740,7 @@
         <p:spPr>
           <a:xfrm>
             <a:off x="5541120" y="3383280"/>
-            <a:ext cx="1663920" cy="1810080"/>
+            <a:ext cx="1663560" cy="1809720"/>
           </a:xfrm>
           <a:prstGeom prst="rect">
             <a:avLst/>
@@ -6973,7 +6977,7 @@
         <p:spPr>
           <a:xfrm>
             <a:off x="7425000" y="2697480"/>
-            <a:ext cx="2331360" cy="2541600"/>
+            <a:ext cx="2331000" cy="2541240"/>
           </a:xfrm>
           <a:prstGeom prst="roundRect">
             <a:avLst>
@@ -6997,7 +7001,7 @@
           <a:fontRef idx="minor"/>
         </p:style>
         <p:txBody>
-          <a:bodyPr lIns="82440" rIns="82440" tIns="64080" anchor="t">
+          <a:bodyPr lIns="82440" rIns="82440" tIns="64080" bIns="45000" anchor="t">
             <a:noAutofit/>
           </a:bodyPr>
           <a:p>
@@ -7014,7 +7018,7 @@
                 <a:uFillTx/>
                 <a:latin typeface="Aptos"/>
                 <a:ea typeface="Aptos"/>
-                <a:hlinkClick r:id="rId28"/>
+                <a:hlinkClick r:id="rId34"/>
               </a:rPr>
               <a:t>Agentic gradient</a:t>
             </a:r>
@@ -7039,7 +7043,7 @@
                 <a:uFillTx/>
                 <a:latin typeface="Aptos"/>
                 <a:ea typeface="Aptos"/>
-                <a:hlinkClick r:id="rId29"/>
+                <a:hlinkClick r:id="rId35"/>
               </a:rPr>
               <a:t>Step 5 · objective-conditioned opportunity</a:t>
             </a:r>
@@ -7061,7 +7065,7 @@
         <p:spPr>
           <a:xfrm>
             <a:off x="7507080" y="3346560"/>
-            <a:ext cx="2166840" cy="1865160"/>
+            <a:ext cx="2166480" cy="1864800"/>
           </a:xfrm>
           <a:prstGeom prst="rect">
             <a:avLst/>
@@ -7347,7 +7351,7 @@
         <p:spPr>
           <a:xfrm>
             <a:off x="9893880" y="2697480"/>
-            <a:ext cx="1728000" cy="2541600"/>
+            <a:ext cx="1727640" cy="2541240"/>
           </a:xfrm>
           <a:prstGeom prst="roundRect">
             <a:avLst>
@@ -7371,7 +7375,7 @@
           <a:fontRef idx="minor"/>
         </p:style>
         <p:txBody>
-          <a:bodyPr lIns="82440" rIns="82440" tIns="64080" anchor="t">
+          <a:bodyPr lIns="82440" rIns="82440" tIns="64080" bIns="45000" anchor="t">
             <a:noAutofit/>
           </a:bodyPr>
           <a:p>
@@ -7431,7 +7435,7 @@
         <p:spPr>
           <a:xfrm>
             <a:off x="9966960" y="3218760"/>
-            <a:ext cx="1590840" cy="1992960"/>
+            <a:ext cx="1590480" cy="1992600"/>
           </a:xfrm>
           <a:prstGeom prst="rect">
             <a:avLst/>
@@ -7718,7 +7722,7 @@
         <p:spPr>
           <a:xfrm>
             <a:off x="567000" y="5376600"/>
-            <a:ext cx="11054880" cy="566640"/>
+            <a:ext cx="11054520" cy="566280"/>
           </a:xfrm>
           <a:prstGeom prst="roundRect">
             <a:avLst>
@@ -7742,7 +7746,7 @@
           <a:fontRef idx="minor"/>
         </p:style>
         <p:txBody>
-          <a:bodyPr lIns="64080" rIns="64080" anchor="t">
+          <a:bodyPr lIns="64080" rIns="64080" tIns="45000" bIns="45000" anchor="t">
             <a:noAutofit/>
           </a:bodyPr>
           <a:p>
@@ -7770,7 +7774,7 @@
         <p:spPr>
           <a:xfrm>
             <a:off x="658440" y="5468040"/>
-            <a:ext cx="2102760" cy="383760"/>
+            <a:ext cx="2102400" cy="383400"/>
           </a:xfrm>
           <a:prstGeom prst="roundRect">
             <a:avLst>
@@ -7808,7 +7812,7 @@
                 <a:uFillTx/>
                 <a:latin typeface="Aptos"/>
                 <a:ea typeface="Aptos"/>
-                <a:hlinkClick r:id="rId30"/>
+                <a:hlinkClick r:id="rId36"/>
               </a:rPr>
               <a:t>MSCA · Minimum Sufficient</a:t>
             </a:r>
@@ -7833,7 +7837,7 @@
                 <a:uFillTx/>
                 <a:latin typeface="Aptos"/>
                 <a:ea typeface="Aptos"/>
-                <a:hlinkClick r:id="rId31"/>
+                <a:hlinkClick r:id="rId37"/>
               </a:rPr>
               <a:t>Control Architecture</a:t>
             </a:r>
@@ -7855,7 +7859,7 @@
         <p:spPr>
           <a:xfrm>
             <a:off x="2880360" y="5431680"/>
-            <a:ext cx="8640720" cy="456840"/>
+            <a:ext cx="8640360" cy="456480"/>
           </a:xfrm>
           <a:prstGeom prst="rect">
             <a:avLst/>
@@ -7945,7 +7949,7 @@
         <p:spPr>
           <a:xfrm>
             <a:off x="1705320" y="6510600"/>
-            <a:ext cx="1288800" cy="104040"/>
+            <a:ext cx="1288440" cy="103680"/>
           </a:xfrm>
           <a:prstGeom prst="rect">
             <a:avLst/>
@@ -7989,7 +7993,7 @@
                 <a:uFillTx/>
                 <a:latin typeface="Calibri"/>
                 <a:ea typeface="Calibri"/>
-                <a:hlinkClick r:id="rId32"/>
+                <a:hlinkClick r:id="rId38"/>
               </a:rPr>
               <a:t>Positioning cycle</a:t>
             </a:r>
@@ -8048,7 +8052,7 @@
         <p:spPr>
           <a:xfrm>
             <a:off x="571680" y="114480"/>
-            <a:ext cx="2666520" cy="190080"/>
+            <a:ext cx="2666160" cy="189720"/>
           </a:xfrm>
           <a:prstGeom prst="rect">
             <a:avLst/>
@@ -8102,7 +8106,7 @@
         <p:spPr>
           <a:xfrm>
             <a:off x="10858680" y="114480"/>
-            <a:ext cx="666360" cy="190080"/>
+            <a:ext cx="666000" cy="189720"/>
           </a:xfrm>
           <a:prstGeom prst="rect">
             <a:avLst/>
@@ -8156,7 +8160,7 @@
         <p:spPr>
           <a:xfrm>
             <a:off x="571680" y="324000"/>
-            <a:ext cx="10953360" cy="14040"/>
+            <a:ext cx="10953000" cy="13680"/>
           </a:xfrm>
           <a:prstGeom prst="rect">
             <a:avLst/>
@@ -8179,6 +8183,11 @@
             <a:noAutofit/>
           </a:bodyPr>
           <a:p>
+            <a:pPr>
+              <a:lnSpc>
+                <a:spcPct val="100000"/>
+              </a:lnSpc>
+            </a:pPr>
             <a:endParaRPr b="0" lang="en-US" sz="1800" spc="-1" strike="noStrike">
               <a:solidFill>
                 <a:srgbClr val="ffffff"/>
@@ -8197,7 +8206,7 @@
         <p:spPr>
           <a:xfrm>
             <a:off x="571680" y="457200"/>
-            <a:ext cx="10953360" cy="399600"/>
+            <a:ext cx="10953000" cy="399240"/>
           </a:xfrm>
           <a:prstGeom prst="rect">
             <a:avLst/>
@@ -8251,7 +8260,7 @@
         <p:spPr>
           <a:xfrm>
             <a:off x="571680" y="847800"/>
-            <a:ext cx="10953360" cy="228240"/>
+            <a:ext cx="10953000" cy="227880"/>
           </a:xfrm>
           <a:prstGeom prst="rect">
             <a:avLst/>
@@ -8305,7 +8314,7 @@
         <p:spPr>
           <a:xfrm>
             <a:off x="571680" y="1181160"/>
-            <a:ext cx="10953360" cy="4343040"/>
+            <a:ext cx="10953000" cy="4342680"/>
           </a:xfrm>
           <a:prstGeom prst="roundRect">
             <a:avLst>
@@ -8333,6 +8342,11 @@
             <a:noAutofit/>
           </a:bodyPr>
           <a:p>
+            <a:pPr>
+              <a:lnSpc>
+                <a:spcPct val="100000"/>
+              </a:lnSpc>
+            </a:pPr>
             <a:endParaRPr b="0" lang="en-US" sz="1800" spc="-1" strike="noStrike">
               <a:solidFill>
                 <a:srgbClr val="000000"/>
@@ -8351,7 +8365,7 @@
         <p:spPr>
           <a:xfrm>
             <a:off x="762120" y="1324080"/>
-            <a:ext cx="10572480" cy="380520"/>
+            <a:ext cx="10572120" cy="380160"/>
           </a:xfrm>
           <a:prstGeom prst="roundRect">
             <a:avLst>
@@ -8376,6 +8390,11 @@
             <a:noAutofit/>
           </a:bodyPr>
           <a:p>
+            <a:pPr>
+              <a:lnSpc>
+                <a:spcPct val="100000"/>
+              </a:lnSpc>
+            </a:pPr>
             <a:endParaRPr b="0" lang="en-US" sz="1800" spc="-1" strike="noStrike">
               <a:solidFill>
                 <a:srgbClr val="ffffff"/>
@@ -8394,7 +8413,7 @@
         <p:spPr>
           <a:xfrm>
             <a:off x="914400" y="1400040"/>
-            <a:ext cx="10267560" cy="228240"/>
+            <a:ext cx="10267200" cy="227880"/>
           </a:xfrm>
           <a:prstGeom prst="rect">
             <a:avLst/>
@@ -8448,7 +8467,7 @@
         <p:spPr>
           <a:xfrm>
             <a:off x="4095720" y="1752480"/>
-            <a:ext cx="3904920" cy="266400"/>
+            <a:ext cx="3904560" cy="266040"/>
           </a:xfrm>
           <a:prstGeom prst="rect">
             <a:avLst/>
@@ -8502,7 +8521,7 @@
         <p:spPr>
           <a:xfrm>
             <a:off x="762120" y="2114640"/>
-            <a:ext cx="2666520" cy="1361880"/>
+            <a:ext cx="2666160" cy="1361520"/>
           </a:xfrm>
           <a:prstGeom prst="roundRect">
             <a:avLst>
@@ -8530,6 +8549,11 @@
             <a:noAutofit/>
           </a:bodyPr>
           <a:p>
+            <a:pPr>
+              <a:lnSpc>
+                <a:spcPct val="100000"/>
+              </a:lnSpc>
+            </a:pPr>
             <a:endParaRPr b="0" lang="en-US" sz="1800" spc="-1" strike="noStrike">
               <a:solidFill>
                 <a:srgbClr val="000000"/>
@@ -8548,7 +8572,7 @@
         <p:spPr>
           <a:xfrm>
             <a:off x="914400" y="2247840"/>
-            <a:ext cx="2361960" cy="285480"/>
+            <a:ext cx="2361600" cy="285120"/>
           </a:xfrm>
           <a:prstGeom prst="rect">
             <a:avLst/>
@@ -8602,7 +8626,7 @@
         <p:spPr>
           <a:xfrm>
             <a:off x="914400" y="2610000"/>
-            <a:ext cx="2361960" cy="323640"/>
+            <a:ext cx="2361600" cy="323280"/>
           </a:xfrm>
           <a:prstGeom prst="rect">
             <a:avLst/>
@@ -8679,7 +8703,7 @@
         <p:spPr>
           <a:xfrm>
             <a:off x="914400" y="2924280"/>
-            <a:ext cx="2361960" cy="304560"/>
+            <a:ext cx="2361600" cy="304200"/>
           </a:xfrm>
           <a:prstGeom prst="rect">
             <a:avLst/>
@@ -8756,7 +8780,7 @@
         <p:spPr>
           <a:xfrm>
             <a:off x="914400" y="3257640"/>
-            <a:ext cx="2361960" cy="161640"/>
+            <a:ext cx="2361600" cy="161280"/>
           </a:xfrm>
           <a:prstGeom prst="rect">
             <a:avLst/>
@@ -8810,7 +8834,7 @@
         <p:spPr>
           <a:xfrm>
             <a:off x="762120" y="3457440"/>
-            <a:ext cx="2666520" cy="1209240"/>
+            <a:ext cx="2666160" cy="1208880"/>
           </a:xfrm>
           <a:prstGeom prst="roundRect">
             <a:avLst>
@@ -8838,6 +8862,11 @@
             <a:noAutofit/>
           </a:bodyPr>
           <a:p>
+            <a:pPr>
+              <a:lnSpc>
+                <a:spcPct val="100000"/>
+              </a:lnSpc>
+            </a:pPr>
             <a:endParaRPr b="0" lang="en-US" sz="1800" spc="-1" strike="noStrike">
               <a:solidFill>
                 <a:srgbClr val="000000"/>
@@ -8856,7 +8885,7 @@
         <p:spPr>
           <a:xfrm>
             <a:off x="952560" y="3600360"/>
-            <a:ext cx="2285640" cy="266400"/>
+            <a:ext cx="2285280" cy="266040"/>
           </a:xfrm>
           <a:prstGeom prst="rect">
             <a:avLst/>
@@ -8910,7 +8939,7 @@
         <p:spPr>
           <a:xfrm>
             <a:off x="952560" y="3895560"/>
-            <a:ext cx="2285640" cy="228240"/>
+            <a:ext cx="2285280" cy="227880"/>
           </a:xfrm>
           <a:prstGeom prst="rect">
             <a:avLst/>
@@ -8964,7 +8993,7 @@
         <p:spPr>
           <a:xfrm>
             <a:off x="952560" y="4181400"/>
-            <a:ext cx="2285640" cy="190080"/>
+            <a:ext cx="2285280" cy="189720"/>
           </a:xfrm>
           <a:prstGeom prst="rect">
             <a:avLst/>
@@ -9018,7 +9047,7 @@
         <p:spPr>
           <a:xfrm>
             <a:off x="952560" y="4400640"/>
-            <a:ext cx="2285640" cy="171000"/>
+            <a:ext cx="2285280" cy="170640"/>
           </a:xfrm>
           <a:prstGeom prst="rect">
             <a:avLst/>
@@ -9072,7 +9101,7 @@
         <p:spPr>
           <a:xfrm>
             <a:off x="3619440" y="2114640"/>
-            <a:ext cx="5047920" cy="2552400"/>
+            <a:ext cx="5047560" cy="2552040"/>
           </a:xfrm>
           <a:prstGeom prst="roundRect">
             <a:avLst>
@@ -9100,6 +9129,11 @@
             <a:noAutofit/>
           </a:bodyPr>
           <a:p>
+            <a:pPr>
+              <a:lnSpc>
+                <a:spcPct val="100000"/>
+              </a:lnSpc>
+            </a:pPr>
             <a:endParaRPr b="0" lang="en-US" sz="1800" spc="-1" strike="noStrike">
               <a:solidFill>
                 <a:srgbClr val="000000"/>
@@ -9118,7 +9152,7 @@
         <p:spPr>
           <a:xfrm>
             <a:off x="3828960" y="2266920"/>
-            <a:ext cx="4628880" cy="266400"/>
+            <a:ext cx="4628520" cy="266040"/>
           </a:xfrm>
           <a:prstGeom prst="rect">
             <a:avLst/>
@@ -9172,7 +9206,7 @@
         <p:spPr>
           <a:xfrm>
             <a:off x="3828960" y="2562120"/>
-            <a:ext cx="4628880" cy="190080"/>
+            <a:ext cx="4628520" cy="189720"/>
           </a:xfrm>
           <a:prstGeom prst="rect">
             <a:avLst/>
@@ -9226,7 +9260,7 @@
         <p:spPr>
           <a:xfrm>
             <a:off x="3828960" y="2847960"/>
-            <a:ext cx="2209320" cy="818640"/>
+            <a:ext cx="2208960" cy="818280"/>
           </a:xfrm>
           <a:prstGeom prst="roundRect">
             <a:avLst>
@@ -9254,6 +9288,11 @@
             <a:noAutofit/>
           </a:bodyPr>
           <a:p>
+            <a:pPr>
+              <a:lnSpc>
+                <a:spcPct val="100000"/>
+              </a:lnSpc>
+            </a:pPr>
             <a:endParaRPr b="0" lang="en-US" sz="1800" spc="-1" strike="noStrike">
               <a:solidFill>
                 <a:srgbClr val="000000"/>
@@ -9272,7 +9311,7 @@
         <p:spPr>
           <a:xfrm>
             <a:off x="3962520" y="3000240"/>
-            <a:ext cx="1942920" cy="190080"/>
+            <a:ext cx="1942560" cy="189720"/>
           </a:xfrm>
           <a:prstGeom prst="rect">
             <a:avLst/>
@@ -9326,7 +9365,7 @@
         <p:spPr>
           <a:xfrm>
             <a:off x="3962520" y="3286080"/>
-            <a:ext cx="1942920" cy="190080"/>
+            <a:ext cx="1942560" cy="189720"/>
           </a:xfrm>
           <a:prstGeom prst="rect">
             <a:avLst/>
@@ -9380,7 +9419,7 @@
         <p:spPr>
           <a:xfrm>
             <a:off x="6248520" y="2847960"/>
-            <a:ext cx="2209320" cy="818640"/>
+            <a:ext cx="2208960" cy="818280"/>
           </a:xfrm>
           <a:prstGeom prst="roundRect">
             <a:avLst>
@@ -9408,6 +9447,11 @@
             <a:noAutofit/>
           </a:bodyPr>
           <a:p>
+            <a:pPr>
+              <a:lnSpc>
+                <a:spcPct val="100000"/>
+              </a:lnSpc>
+            </a:pPr>
             <a:endParaRPr b="0" lang="en-US" sz="1800" spc="-1" strike="noStrike">
               <a:solidFill>
                 <a:srgbClr val="000000"/>
@@ -9426,7 +9470,7 @@
         <p:spPr>
           <a:xfrm>
             <a:off x="6381720" y="3000240"/>
-            <a:ext cx="1942920" cy="190080"/>
+            <a:ext cx="1942560" cy="189720"/>
           </a:xfrm>
           <a:prstGeom prst="rect">
             <a:avLst/>
@@ -9480,7 +9524,7 @@
         <p:spPr>
           <a:xfrm>
             <a:off x="6381720" y="3238560"/>
-            <a:ext cx="1942920" cy="342720"/>
+            <a:ext cx="1942560" cy="342360"/>
           </a:xfrm>
           <a:prstGeom prst="rect">
             <a:avLst/>
@@ -9557,7 +9601,7 @@
         <p:spPr>
           <a:xfrm>
             <a:off x="4495680" y="3848040"/>
-            <a:ext cx="3295440" cy="571320"/>
+            <a:ext cx="3295080" cy="570960"/>
           </a:xfrm>
           <a:prstGeom prst="roundRect">
             <a:avLst>
@@ -9585,6 +9629,11 @@
             <a:noAutofit/>
           </a:bodyPr>
           <a:p>
+            <a:pPr>
+              <a:lnSpc>
+                <a:spcPct val="100000"/>
+              </a:lnSpc>
+            </a:pPr>
             <a:endParaRPr b="0" lang="en-US" sz="1800" spc="-1" strike="noStrike">
               <a:solidFill>
                 <a:srgbClr val="ffffff"/>
@@ -9603,7 +9652,7 @@
         <p:spPr>
           <a:xfrm>
             <a:off x="4667400" y="3943440"/>
-            <a:ext cx="2952360" cy="190080"/>
+            <a:ext cx="2952000" cy="189720"/>
           </a:xfrm>
           <a:prstGeom prst="rect">
             <a:avLst/>
@@ -9657,7 +9706,7 @@
         <p:spPr>
           <a:xfrm>
             <a:off x="4667400" y="4172040"/>
-            <a:ext cx="2952360" cy="171000"/>
+            <a:ext cx="2952000" cy="170640"/>
           </a:xfrm>
           <a:prstGeom prst="rect">
             <a:avLst/>
@@ -9711,7 +9760,7 @@
         <p:spPr>
           <a:xfrm>
             <a:off x="8858160" y="2114640"/>
-            <a:ext cx="2476080" cy="2552400"/>
+            <a:ext cx="2475720" cy="2552040"/>
           </a:xfrm>
           <a:prstGeom prst="roundRect">
             <a:avLst>
@@ -9739,6 +9788,11 @@
             <a:noAutofit/>
           </a:bodyPr>
           <a:p>
+            <a:pPr>
+              <a:lnSpc>
+                <a:spcPct val="100000"/>
+              </a:lnSpc>
+            </a:pPr>
             <a:endParaRPr b="0" lang="en-US" sz="1800" spc="-1" strike="noStrike">
               <a:solidFill>
                 <a:srgbClr val="000000"/>
@@ -9757,7 +9811,7 @@
         <p:spPr>
           <a:xfrm>
             <a:off x="9010800" y="2266920"/>
-            <a:ext cx="2171520" cy="399600"/>
+            <a:ext cx="2171160" cy="399240"/>
           </a:xfrm>
           <a:prstGeom prst="rect">
             <a:avLst/>
@@ -9834,7 +9888,7 @@
         <p:spPr>
           <a:xfrm>
             <a:off x="9010800" y="2724120"/>
-            <a:ext cx="2171520" cy="190080"/>
+            <a:ext cx="2171160" cy="189720"/>
           </a:xfrm>
           <a:prstGeom prst="rect">
             <a:avLst/>
@@ -9888,7 +9942,7 @@
         <p:spPr>
           <a:xfrm>
             <a:off x="9029880" y="2990880"/>
-            <a:ext cx="2133360" cy="1466640"/>
+            <a:ext cx="2133000" cy="1466280"/>
           </a:xfrm>
           <a:prstGeom prst="rect">
             <a:avLst/>
@@ -10047,7 +10101,7 @@
         <p:spPr>
           <a:xfrm>
             <a:off x="762120" y="4857840"/>
-            <a:ext cx="10572480" cy="552240"/>
+            <a:ext cx="10572120" cy="551880"/>
           </a:xfrm>
           <a:prstGeom prst="roundRect">
             <a:avLst>
@@ -10075,6 +10129,11 @@
             <a:noAutofit/>
           </a:bodyPr>
           <a:p>
+            <a:pPr>
+              <a:lnSpc>
+                <a:spcPct val="100000"/>
+              </a:lnSpc>
+            </a:pPr>
             <a:endParaRPr b="0" lang="en-US" sz="1800" spc="-1" strike="noStrike">
               <a:solidFill>
                 <a:srgbClr val="ffffff"/>
@@ -10093,7 +10152,7 @@
         <p:spPr>
           <a:xfrm>
             <a:off x="933480" y="4971960"/>
-            <a:ext cx="2857320" cy="256680"/>
+            <a:ext cx="2856960" cy="256320"/>
           </a:xfrm>
           <a:prstGeom prst="rect">
             <a:avLst/>
@@ -10147,7 +10206,7 @@
         <p:spPr>
           <a:xfrm>
             <a:off x="3905280" y="4952880"/>
-            <a:ext cx="3142800" cy="323640"/>
+            <a:ext cx="3142440" cy="323280"/>
           </a:xfrm>
           <a:prstGeom prst="rect">
             <a:avLst/>
@@ -10224,7 +10283,7 @@
         <p:spPr>
           <a:xfrm>
             <a:off x="7372440" y="4952880"/>
-            <a:ext cx="2857320" cy="323640"/>
+            <a:ext cx="2856960" cy="323280"/>
           </a:xfrm>
           <a:prstGeom prst="rect">
             <a:avLst/>
@@ -10301,7 +10360,7 @@
         <p:spPr>
           <a:xfrm>
             <a:off x="571680" y="5734080"/>
-            <a:ext cx="1190160" cy="190080"/>
+            <a:ext cx="1189800" cy="189720"/>
           </a:xfrm>
           <a:prstGeom prst="rect">
             <a:avLst/>
@@ -10355,7 +10414,7 @@
         <p:spPr>
           <a:xfrm>
             <a:off x="1762200" y="5686560"/>
-            <a:ext cx="9762840" cy="399600"/>
+            <a:ext cx="9762480" cy="399240"/>
           </a:xfrm>
           <a:prstGeom prst="rect">
             <a:avLst/>
@@ -10409,7 +10468,7 @@
         <p:spPr>
           <a:xfrm>
             <a:off x="571680" y="6419880"/>
-            <a:ext cx="10953360" cy="14040"/>
+            <a:ext cx="10953000" cy="13680"/>
           </a:xfrm>
           <a:prstGeom prst="rect">
             <a:avLst/>
@@ -10432,6 +10491,11 @@
             <a:noAutofit/>
           </a:bodyPr>
           <a:p>
+            <a:pPr>
+              <a:lnSpc>
+                <a:spcPct val="100000"/>
+              </a:lnSpc>
+            </a:pPr>
             <a:endParaRPr b="0" lang="en-US" sz="1800" spc="-1" strike="noStrike">
               <a:solidFill>
                 <a:srgbClr val="ffffff"/>
@@ -10450,7 +10514,7 @@
         <p:spPr>
           <a:xfrm>
             <a:off x="571680" y="6486480"/>
-            <a:ext cx="3714480" cy="171000"/>
+            <a:ext cx="3714120" cy="170640"/>
           </a:xfrm>
           <a:prstGeom prst="rect">
             <a:avLst/>
@@ -10504,7 +10568,7 @@
         <p:spPr>
           <a:xfrm>
             <a:off x="4286160" y="6486480"/>
-            <a:ext cx="3619080" cy="171000"/>
+            <a:ext cx="3618720" cy="170640"/>
           </a:xfrm>
           <a:prstGeom prst="rect">
             <a:avLst/>
@@ -10558,7 +10622,7 @@
         <p:spPr>
           <a:xfrm>
             <a:off x="11096640" y="6486480"/>
-            <a:ext cx="333000" cy="171000"/>
+            <a:ext cx="332640" cy="170640"/>
           </a:xfrm>
           <a:prstGeom prst="rect">
             <a:avLst/>
@@ -10642,7 +10706,7 @@
         <p:spPr>
           <a:xfrm>
             <a:off x="0" y="0"/>
-            <a:ext cx="12191400" cy="840960"/>
+            <a:ext cx="12191040" cy="840600"/>
           </a:xfrm>
           <a:prstGeom prst="rect">
             <a:avLst/>
@@ -10695,7 +10759,7 @@
         <p:spPr>
           <a:xfrm>
             <a:off x="0" y="5989320"/>
-            <a:ext cx="12191400" cy="868320"/>
+            <a:ext cx="12191040" cy="867960"/>
           </a:xfrm>
           <a:prstGeom prst="rect">
             <a:avLst/>
@@ -10748,7 +10812,7 @@
         <p:spPr>
           <a:xfrm>
             <a:off x="11018520" y="6546960"/>
-            <a:ext cx="319680" cy="219240"/>
+            <a:ext cx="319320" cy="219240"/>
           </a:xfrm>
           <a:prstGeom prst="rect">
             <a:avLst/>
@@ -10802,7 +10866,7 @@
         <p:spPr>
           <a:xfrm>
             <a:off x="384120" y="182880"/>
-            <a:ext cx="11338200" cy="383760"/>
+            <a:ext cx="11337840" cy="383400"/>
           </a:xfrm>
           <a:prstGeom prst="rect">
             <a:avLst/>
@@ -10858,7 +10922,7 @@
         <p:spPr>
           <a:xfrm>
             <a:off x="384120" y="548640"/>
-            <a:ext cx="11338200" cy="356400"/>
+            <a:ext cx="11337840" cy="356040"/>
           </a:xfrm>
           <a:prstGeom prst="rect">
             <a:avLst/>
@@ -10935,7 +10999,7 @@
         <p:spPr>
           <a:xfrm>
             <a:off x="274320" y="987480"/>
-            <a:ext cx="2148480" cy="1188360"/>
+            <a:ext cx="2148120" cy="1188000"/>
           </a:xfrm>
           <a:prstGeom prst="roundRect">
             <a:avLst>
@@ -11048,7 +11112,7 @@
         <p:spPr>
           <a:xfrm>
             <a:off x="2505600" y="987480"/>
-            <a:ext cx="1846800" cy="575640"/>
+            <a:ext cx="1846440" cy="575280"/>
           </a:xfrm>
           <a:prstGeom prst="roundRect">
             <a:avLst>
@@ -11135,7 +11199,7 @@
         <p:spPr>
           <a:xfrm>
             <a:off x="2505600" y="1600200"/>
-            <a:ext cx="1846800" cy="575640"/>
+            <a:ext cx="1846440" cy="575280"/>
           </a:xfrm>
           <a:prstGeom prst="roundRect">
             <a:avLst>
@@ -11222,7 +11286,7 @@
         <p:spPr>
           <a:xfrm>
             <a:off x="274320" y="2404800"/>
-            <a:ext cx="2148480" cy="1188360"/>
+            <a:ext cx="2148120" cy="1188000"/>
           </a:xfrm>
           <a:prstGeom prst="roundRect">
             <a:avLst>
@@ -11335,7 +11399,7 @@
         <p:spPr>
           <a:xfrm>
             <a:off x="2505600" y="2404800"/>
-            <a:ext cx="1846800" cy="575640"/>
+            <a:ext cx="1846440" cy="575280"/>
           </a:xfrm>
           <a:prstGeom prst="roundRect">
             <a:avLst>
@@ -11422,7 +11486,7 @@
         <p:spPr>
           <a:xfrm>
             <a:off x="2505600" y="3017520"/>
-            <a:ext cx="1846800" cy="575640"/>
+            <a:ext cx="1846440" cy="575280"/>
           </a:xfrm>
           <a:prstGeom prst="roundRect">
             <a:avLst>
@@ -11509,7 +11573,7 @@
         <p:spPr>
           <a:xfrm>
             <a:off x="274320" y="3822120"/>
-            <a:ext cx="2148480" cy="1188360"/>
+            <a:ext cx="2148120" cy="1188000"/>
           </a:xfrm>
           <a:prstGeom prst="roundRect">
             <a:avLst>
@@ -11622,7 +11686,7 @@
         <p:spPr>
           <a:xfrm>
             <a:off x="2505600" y="3822120"/>
-            <a:ext cx="1846800" cy="575640"/>
+            <a:ext cx="1846440" cy="575280"/>
           </a:xfrm>
           <a:prstGeom prst="roundRect">
             <a:avLst>
@@ -11709,7 +11773,7 @@
         <p:spPr>
           <a:xfrm>
             <a:off x="2505600" y="4434840"/>
-            <a:ext cx="1846800" cy="575640"/>
+            <a:ext cx="1846440" cy="575280"/>
           </a:xfrm>
           <a:prstGeom prst="roundRect">
             <a:avLst>
@@ -11796,7 +11860,7 @@
         <p:spPr>
           <a:xfrm>
             <a:off x="9765720" y="987480"/>
-            <a:ext cx="2148480" cy="1188360"/>
+            <a:ext cx="2148120" cy="1188000"/>
           </a:xfrm>
           <a:prstGeom prst="roundRect">
             <a:avLst>
@@ -11909,7 +11973,7 @@
         <p:spPr>
           <a:xfrm>
             <a:off x="7836480" y="987480"/>
-            <a:ext cx="1846800" cy="575640"/>
+            <a:ext cx="1846440" cy="575280"/>
           </a:xfrm>
           <a:prstGeom prst="roundRect">
             <a:avLst>
@@ -11996,7 +12060,7 @@
         <p:spPr>
           <a:xfrm>
             <a:off x="7836480" y="1600200"/>
-            <a:ext cx="1846800" cy="575640"/>
+            <a:ext cx="1846440" cy="575280"/>
           </a:xfrm>
           <a:prstGeom prst="roundRect">
             <a:avLst>
@@ -12083,7 +12147,7 @@
         <p:spPr>
           <a:xfrm>
             <a:off x="9765720" y="2404800"/>
-            <a:ext cx="2148480" cy="1188360"/>
+            <a:ext cx="2148120" cy="1188000"/>
           </a:xfrm>
           <a:prstGeom prst="roundRect">
             <a:avLst>
@@ -12196,7 +12260,7 @@
         <p:spPr>
           <a:xfrm>
             <a:off x="7836480" y="2404800"/>
-            <a:ext cx="1846800" cy="575640"/>
+            <a:ext cx="1846440" cy="575280"/>
           </a:xfrm>
           <a:prstGeom prst="roundRect">
             <a:avLst>
@@ -12283,7 +12347,7 @@
         <p:spPr>
           <a:xfrm>
             <a:off x="7836480" y="3017520"/>
-            <a:ext cx="1846800" cy="575640"/>
+            <a:ext cx="1846440" cy="575280"/>
           </a:xfrm>
           <a:prstGeom prst="roundRect">
             <a:avLst>
@@ -12370,7 +12434,7 @@
         <p:spPr>
           <a:xfrm>
             <a:off x="9765720" y="3822120"/>
-            <a:ext cx="2148480" cy="1188360"/>
+            <a:ext cx="2148120" cy="1188000"/>
           </a:xfrm>
           <a:prstGeom prst="roundRect">
             <a:avLst>
@@ -12483,7 +12547,7 @@
         <p:spPr>
           <a:xfrm>
             <a:off x="7836480" y="3822120"/>
-            <a:ext cx="1846800" cy="575640"/>
+            <a:ext cx="1846440" cy="575280"/>
           </a:xfrm>
           <a:prstGeom prst="roundRect">
             <a:avLst>
@@ -12570,7 +12634,7 @@
         <p:spPr>
           <a:xfrm>
             <a:off x="7836480" y="4434840"/>
-            <a:ext cx="1846800" cy="575640"/>
+            <a:ext cx="1846440" cy="575280"/>
           </a:xfrm>
           <a:prstGeom prst="roundRect">
             <a:avLst>
@@ -12657,7 +12721,7 @@
         <p:spPr>
           <a:xfrm>
             <a:off x="4480560" y="914400"/>
-            <a:ext cx="3227400" cy="603000"/>
+            <a:ext cx="3227040" cy="602640"/>
           </a:xfrm>
           <a:prstGeom prst="roundRect">
             <a:avLst>
@@ -12681,7 +12745,7 @@
           <a:fontRef idx="minor"/>
         </p:style>
         <p:txBody>
-          <a:bodyPr lIns="82440" rIns="73080" bIns="27360" anchor="t">
+          <a:bodyPr lIns="82440" rIns="73080" tIns="45000" bIns="27360" anchor="t">
             <a:noAutofit/>
           </a:bodyPr>
           <a:p>
@@ -12744,7 +12808,7 @@
         <p:spPr>
           <a:xfrm>
             <a:off x="4480560" y="1572840"/>
-            <a:ext cx="1581480" cy="575640"/>
+            <a:ext cx="1581120" cy="575280"/>
           </a:xfrm>
           <a:prstGeom prst="roundRect">
             <a:avLst>
@@ -12831,7 +12895,7 @@
         <p:spPr>
           <a:xfrm>
             <a:off x="6126480" y="1572840"/>
-            <a:ext cx="1581480" cy="575640"/>
+            <a:ext cx="1581120" cy="575280"/>
           </a:xfrm>
           <a:prstGeom prst="roundRect">
             <a:avLst>
@@ -12918,7 +12982,7 @@
         <p:spPr>
           <a:xfrm>
             <a:off x="4480560" y="2240280"/>
-            <a:ext cx="3227400" cy="2084400"/>
+            <a:ext cx="3227040" cy="2084040"/>
           </a:xfrm>
           <a:prstGeom prst="roundRect">
             <a:avLst>
@@ -13168,7 +13232,7 @@
         <p:spPr>
           <a:xfrm>
             <a:off x="4480560" y="4389120"/>
-            <a:ext cx="1581480" cy="575640"/>
+            <a:ext cx="1581120" cy="575280"/>
           </a:xfrm>
           <a:prstGeom prst="roundRect">
             <a:avLst>
@@ -13255,7 +13319,7 @@
         <p:spPr>
           <a:xfrm>
             <a:off x="6126480" y="4389120"/>
-            <a:ext cx="1581480" cy="575640"/>
+            <a:ext cx="1581120" cy="575280"/>
           </a:xfrm>
           <a:prstGeom prst="roundRect">
             <a:avLst>
@@ -13342,7 +13406,7 @@
         <p:spPr>
           <a:xfrm>
             <a:off x="4480560" y="5029200"/>
-            <a:ext cx="3227400" cy="731160"/>
+            <a:ext cx="3227040" cy="730800"/>
           </a:xfrm>
           <a:prstGeom prst="roundRect">
             <a:avLst>
@@ -13366,7 +13430,7 @@
           <a:fontRef idx="minor"/>
         </p:style>
         <p:txBody>
-          <a:bodyPr lIns="82440" rIns="73080" bIns="27360" anchor="t">
+          <a:bodyPr lIns="82440" rIns="73080" tIns="45000" bIns="27360" anchor="t">
             <a:noAutofit/>
           </a:bodyPr>
           <a:p>
@@ -13455,7 +13519,7 @@
         <p:spPr>
           <a:xfrm>
             <a:off x="384120" y="6035040"/>
-            <a:ext cx="10332360" cy="383760"/>
+            <a:ext cx="10332000" cy="383400"/>
           </a:xfrm>
           <a:prstGeom prst="roundRect">
             <a:avLst>
@@ -13479,7 +13543,7 @@
           <a:fontRef idx="minor"/>
         </p:style>
         <p:txBody>
-          <a:bodyPr lIns="64080" rIns="64080" anchor="t">
+          <a:bodyPr lIns="64080" rIns="64080" tIns="45000" bIns="45000" anchor="t">
             <a:noAutofit/>
           </a:bodyPr>
           <a:p>
@@ -13507,7 +13571,7 @@
         <p:spPr>
           <a:xfrm>
             <a:off x="502920" y="6062400"/>
-            <a:ext cx="10149480" cy="347040"/>
+            <a:ext cx="10149120" cy="346680"/>
           </a:xfrm>
           <a:prstGeom prst="rect">
             <a:avLst/>
@@ -13637,7 +13701,7 @@
         <p:spPr>
           <a:xfrm>
             <a:off x="1332000" y="6510600"/>
-            <a:ext cx="2035440" cy="104040"/>
+            <a:ext cx="2035080" cy="103680"/>
           </a:xfrm>
           <a:prstGeom prst="rect">
             <a:avLst/>
@@ -13733,7 +13797,7 @@
         <p:spPr>
           <a:xfrm>
             <a:off x="255960" y="182880"/>
-            <a:ext cx="9875160" cy="310680"/>
+            <a:ext cx="9874800" cy="310320"/>
           </a:xfrm>
           <a:prstGeom prst="rect">
             <a:avLst/>
@@ -13778,7 +13842,7 @@
         <p:spPr>
           <a:xfrm>
             <a:off x="255960" y="502920"/>
-            <a:ext cx="10972440" cy="164160"/>
+            <a:ext cx="10972080" cy="163800"/>
           </a:xfrm>
           <a:prstGeom prst="rect">
             <a:avLst/>
@@ -13823,7 +13887,7 @@
         <p:spPr>
           <a:xfrm>
             <a:off x="320040" y="822960"/>
-            <a:ext cx="2175840" cy="768096"/>
+            <a:ext cx="2175480" cy="768096"/>
           </a:xfrm>
           <a:prstGeom prst="roundRect">
             <a:avLst>
@@ -13907,7 +13971,7 @@
               </a:rPr>
               <a:t>Governance</a:t>
             </a:r>
-            <a:endParaRPr b="0" lang="en-US" sz="780" spc="-1" strike="noStrike">
+            <a:endParaRPr b="0" lang="en-US" sz="720" spc="-1" strike="noStrike">
               <a:solidFill>
                 <a:srgbClr val="000000"/>
               </a:solidFill>
@@ -13936,7 +14000,7 @@
               </a:rPr>
               <a:t>Objectives, rights, legitimacy, accountability,</a:t>
             </a:r>
-            <a:endParaRPr b="0" lang="en-US" sz="780" spc="-1" strike="noStrike">
+            <a:endParaRPr b="0" lang="en-US" sz="720" spc="-1" strike="noStrike">
               <a:solidFill>
                 <a:srgbClr val="000000"/>
               </a:solidFill>
@@ -13965,7 +14029,7 @@
               </a:rPr>
               <a:t>legal / organizational constraints.</a:t>
             </a:r>
-            <a:endParaRPr b="0" lang="en-US" sz="780" spc="-1" strike="noStrike">
+            <a:endParaRPr b="0" lang="en-US" sz="720" spc="-1" strike="noStrike">
               <a:solidFill>
                 <a:srgbClr val="000000"/>
               </a:solidFill>
@@ -13983,7 +14047,7 @@
         <p:spPr>
           <a:xfrm>
             <a:off x="2862000" y="822960"/>
-            <a:ext cx="2175840" cy="768096"/>
+            <a:ext cx="2175480" cy="768096"/>
           </a:xfrm>
           <a:prstGeom prst="roundRect">
             <a:avLst>
@@ -14067,7 +14131,7 @@
               </a:rPr>
               <a:t>Governance</a:t>
             </a:r>
-            <a:endParaRPr b="0" lang="en-US" sz="780" spc="-1" strike="noStrike">
+            <a:endParaRPr b="0" lang="en-US" sz="720" spc="-1" strike="noStrike">
               <a:solidFill>
                 <a:srgbClr val="000000"/>
               </a:solidFill>
@@ -14096,7 +14160,7 @@
               </a:rPr>
               <a:t>Consent, disclosure limits, data minimization,</a:t>
             </a:r>
-            <a:endParaRPr b="0" lang="en-US" sz="780" spc="-1" strike="noStrike">
+            <a:endParaRPr b="0" lang="en-US" sz="720" spc="-1" strike="noStrike">
               <a:solidFill>
                 <a:srgbClr val="000000"/>
               </a:solidFill>
@@ -14125,7 +14189,7 @@
               </a:rPr>
               <a:t>correlation and privacy boundaries.</a:t>
             </a:r>
-            <a:endParaRPr b="0" lang="en-US" sz="780" spc="-1" strike="noStrike">
+            <a:endParaRPr b="0" lang="en-US" sz="720" spc="-1" strike="noStrike">
               <a:solidFill>
                 <a:srgbClr val="000000"/>
               </a:solidFill>
@@ -14143,7 +14207,7 @@
         <p:spPr>
           <a:xfrm>
             <a:off x="5413320" y="822960"/>
-            <a:ext cx="2175840" cy="768096"/>
+            <a:ext cx="2175480" cy="768096"/>
           </a:xfrm>
           <a:prstGeom prst="roundRect">
             <a:avLst>
@@ -14227,7 +14291,7 @@
               </a:rPr>
               <a:t>Membership</a:t>
             </a:r>
-            <a:endParaRPr b="0" lang="en-US" sz="780" spc="-1" strike="noStrike">
+            <a:endParaRPr b="0" lang="en-US" sz="720" spc="-1" strike="noStrike">
               <a:solidFill>
                 <a:srgbClr val="000000"/>
               </a:solidFill>
@@ -14256,7 +14320,7 @@
               </a:rPr>
               <a:t>Organizational role models, membership,</a:t>
             </a:r>
-            <a:endParaRPr b="0" lang="en-US" sz="780" spc="-1" strike="noStrike">
+            <a:endParaRPr b="0" lang="en-US" sz="720" spc="-1" strike="noStrike">
               <a:solidFill>
                 <a:srgbClr val="000000"/>
               </a:solidFill>
@@ -14285,7 +14349,7 @@
               </a:rPr>
               <a:t>ownership and participation context.</a:t>
             </a:r>
-            <a:endParaRPr b="0" lang="en-US" sz="780" spc="-1" strike="noStrike">
+            <a:endParaRPr b="0" lang="en-US" sz="720" spc="-1" strike="noStrike">
               <a:solidFill>
                 <a:srgbClr val="000000"/>
               </a:solidFill>
@@ -14303,7 +14367,7 @@
         <p:spPr>
           <a:xfrm>
             <a:off x="7955280" y="822960"/>
-            <a:ext cx="2175840" cy="768096"/>
+            <a:ext cx="2175480" cy="768096"/>
           </a:xfrm>
           <a:prstGeom prst="roundRect">
             <a:avLst>
@@ -14387,7 +14451,7 @@
               </a:rPr>
               <a:t>Conformance</a:t>
             </a:r>
-            <a:endParaRPr b="0" lang="en-US" sz="780" spc="-1" strike="noStrike">
+            <a:endParaRPr b="0" lang="en-US" sz="720" spc="-1" strike="noStrike">
               <a:solidFill>
                 <a:srgbClr val="000000"/>
               </a:solidFill>
@@ -14416,7 +14480,7 @@
               </a:rPr>
               <a:t>Versioned profiles, schemas, interoperability</a:t>
             </a:r>
-            <a:endParaRPr b="0" lang="en-US" sz="780" spc="-1" strike="noStrike">
+            <a:endParaRPr b="0" lang="en-US" sz="720" spc="-1" strike="noStrike">
               <a:solidFill>
                 <a:srgbClr val="000000"/>
               </a:solidFill>
@@ -14445,7 +14509,7 @@
               </a:rPr>
               <a:t>mappings and conformance fixtures.</a:t>
             </a:r>
-            <a:endParaRPr b="0" lang="en-US" sz="780" spc="-1" strike="noStrike">
+            <a:endParaRPr b="0" lang="en-US" sz="720" spc="-1" strike="noStrike">
               <a:solidFill>
                 <a:srgbClr val="000000"/>
               </a:solidFill>
@@ -14463,7 +14527,7 @@
         <p:spPr>
           <a:xfrm>
             <a:off x="311040" y="1810440"/>
-            <a:ext cx="2084400" cy="566640"/>
+            <a:ext cx="2084040" cy="566280"/>
           </a:xfrm>
           <a:prstGeom prst="roundRect">
             <a:avLst>
@@ -14530,7 +14594,7 @@
         <p:spPr>
           <a:xfrm>
             <a:off x="311040" y="2587680"/>
-            <a:ext cx="2084400" cy="566640"/>
+            <a:ext cx="2084040" cy="566280"/>
           </a:xfrm>
           <a:prstGeom prst="roundRect">
             <a:avLst>
@@ -14597,7 +14661,7 @@
         <p:spPr>
           <a:xfrm>
             <a:off x="311040" y="3364920"/>
-            <a:ext cx="2084400" cy="566640"/>
+            <a:ext cx="2084040" cy="566280"/>
           </a:xfrm>
           <a:prstGeom prst="roundRect">
             <a:avLst>
@@ -14664,7 +14728,7 @@
         <p:spPr>
           <a:xfrm>
             <a:off x="311040" y="4142160"/>
-            <a:ext cx="2084400" cy="566640"/>
+            <a:ext cx="2084040" cy="566280"/>
           </a:xfrm>
           <a:prstGeom prst="roundRect">
             <a:avLst>
@@ -14731,7 +14795,7 @@
         <p:spPr>
           <a:xfrm>
             <a:off x="311040" y="4919400"/>
-            <a:ext cx="2084400" cy="566640"/>
+            <a:ext cx="2084040" cy="566280"/>
           </a:xfrm>
           <a:prstGeom prst="roundRect">
             <a:avLst>
@@ -14798,7 +14862,7 @@
         <p:spPr>
           <a:xfrm>
             <a:off x="311040" y="5696640"/>
-            <a:ext cx="2084400" cy="566640"/>
+            <a:ext cx="2084040" cy="566280"/>
           </a:xfrm>
           <a:prstGeom prst="roundRect">
             <a:avLst>
@@ -14865,7 +14929,7 @@
         <p:spPr>
           <a:xfrm>
             <a:off x="9555480" y="1810440"/>
-            <a:ext cx="2239920" cy="566640"/>
+            <a:ext cx="2239560" cy="566280"/>
           </a:xfrm>
           <a:prstGeom prst="roundRect">
             <a:avLst>
@@ -14932,7 +14996,7 @@
         <p:spPr>
           <a:xfrm>
             <a:off x="9555480" y="2587680"/>
-            <a:ext cx="2239920" cy="566640"/>
+            <a:ext cx="2239560" cy="566280"/>
           </a:xfrm>
           <a:prstGeom prst="roundRect">
             <a:avLst>
@@ -14999,7 +15063,7 @@
         <p:spPr>
           <a:xfrm>
             <a:off x="9555480" y="3364920"/>
-            <a:ext cx="2239920" cy="566640"/>
+            <a:ext cx="2239560" cy="566280"/>
           </a:xfrm>
           <a:prstGeom prst="roundRect">
             <a:avLst>
@@ -15066,7 +15130,7 @@
         <p:spPr>
           <a:xfrm>
             <a:off x="9555480" y="4142160"/>
-            <a:ext cx="2239920" cy="566640"/>
+            <a:ext cx="2239560" cy="566280"/>
           </a:xfrm>
           <a:prstGeom prst="roundRect">
             <a:avLst>
@@ -15133,7 +15197,7 @@
         <p:spPr>
           <a:xfrm>
             <a:off x="9555480" y="4919400"/>
-            <a:ext cx="2239920" cy="566640"/>
+            <a:ext cx="2239560" cy="566280"/>
           </a:xfrm>
           <a:prstGeom prst="roundRect">
             <a:avLst>
@@ -15200,7 +15264,7 @@
         <p:spPr>
           <a:xfrm>
             <a:off x="9555480" y="5696640"/>
-            <a:ext cx="2239920" cy="566640"/>
+            <a:ext cx="2239560" cy="566280"/>
           </a:xfrm>
           <a:prstGeom prst="roundRect">
             <a:avLst>
@@ -15267,7 +15331,7 @@
         <p:spPr>
           <a:xfrm>
             <a:off x="2761560" y="5687640"/>
-            <a:ext cx="1325520" cy="603000"/>
+            <a:ext cx="1325160" cy="602640"/>
           </a:xfrm>
           <a:prstGeom prst="roundRect">
             <a:avLst>
@@ -15357,7 +15421,7 @@
         <p:spPr>
           <a:xfrm>
             <a:off x="4316040" y="5687640"/>
-            <a:ext cx="1325520" cy="603000"/>
+            <a:ext cx="1325160" cy="602640"/>
           </a:xfrm>
           <a:prstGeom prst="roundRect">
             <a:avLst>
@@ -15447,7 +15511,7 @@
         <p:spPr>
           <a:xfrm>
             <a:off x="5906880" y="5687640"/>
-            <a:ext cx="1325520" cy="603000"/>
+            <a:ext cx="1325160" cy="602640"/>
           </a:xfrm>
           <a:prstGeom prst="roundRect">
             <a:avLst>
@@ -15537,7 +15601,7 @@
         <p:spPr>
           <a:xfrm>
             <a:off x="7525440" y="5687640"/>
-            <a:ext cx="1325520" cy="603000"/>
+            <a:ext cx="1325160" cy="602640"/>
           </a:xfrm>
           <a:prstGeom prst="roundRect">
             <a:avLst>
@@ -15627,7 +15691,7 @@
         <p:spPr>
           <a:xfrm>
             <a:off x="2724840" y="6400800"/>
-            <a:ext cx="6903360" cy="145800"/>
+            <a:ext cx="6903000" cy="145440"/>
           </a:xfrm>
           <a:prstGeom prst="rect">
             <a:avLst/>
@@ -15672,7 +15736,7 @@
         <p:spPr>
           <a:xfrm>
             <a:off x="0" y="0"/>
-            <a:ext cx="12191400" cy="785880"/>
+            <a:ext cx="12191040" cy="785520"/>
           </a:xfrm>
           <a:prstGeom prst="rect">
             <a:avLst/>
@@ -15725,7 +15789,7 @@
         <p:spPr>
           <a:xfrm>
             <a:off x="292680" y="237600"/>
-            <a:ext cx="10972440" cy="355680"/>
+            <a:ext cx="10972080" cy="355680"/>
           </a:xfrm>
           <a:prstGeom prst="rect">
             <a:avLst/>
@@ -15781,7 +15845,7 @@
         <p:spPr>
           <a:xfrm>
             <a:off x="292680" y="530280"/>
-            <a:ext cx="10972440" cy="206280"/>
+            <a:ext cx="10972080" cy="206280"/>
           </a:xfrm>
           <a:prstGeom prst="rect">
             <a:avLst/>
@@ -15835,7 +15899,7 @@
         <p:spPr>
           <a:xfrm>
             <a:off x="0" y="6327720"/>
-            <a:ext cx="12191400" cy="529920"/>
+            <a:ext cx="12191040" cy="529560"/>
           </a:xfrm>
           <a:prstGeom prst="rect">
             <a:avLst/>
@@ -15888,7 +15952,7 @@
         <p:spPr>
           <a:xfrm>
             <a:off x="2834640" y="6382440"/>
-            <a:ext cx="6537600" cy="318600"/>
+            <a:ext cx="6537240" cy="318600"/>
           </a:xfrm>
           <a:prstGeom prst="rect">
             <a:avLst/>
@@ -15942,7 +16006,7 @@
         <p:spPr>
           <a:xfrm>
             <a:off x="11018520" y="6546960"/>
-            <a:ext cx="319680" cy="219240"/>
+            <a:ext cx="319320" cy="219240"/>
           </a:xfrm>
           <a:prstGeom prst="rect">
             <a:avLst/>
@@ -16836,7 +16900,7 @@
         <p:spPr>
           <a:xfrm>
             <a:off x="4370760" y="2103120"/>
-            <a:ext cx="3200040" cy="2852640"/>
+            <a:ext cx="3199680" cy="2852280"/>
           </a:xfrm>
           <a:prstGeom prst="roundRect">
             <a:avLst>
@@ -16860,7 +16924,7 @@
           <a:fontRef idx="minor"/>
         </p:style>
         <p:txBody>
-          <a:bodyPr lIns="64080" rIns="64080" anchor="t">
+          <a:bodyPr lIns="64080" rIns="64080" tIns="45000" bIns="45000" anchor="t">
             <a:noAutofit/>
           </a:bodyPr>
           <a:p>
@@ -16888,7 +16952,7 @@
         <p:spPr>
           <a:xfrm>
             <a:off x="4462200" y="2194560"/>
-            <a:ext cx="3017160" cy="273960"/>
+            <a:ext cx="3016800" cy="273600"/>
           </a:xfrm>
           <a:prstGeom prst="rect">
             <a:avLst/>
@@ -16944,7 +17008,7 @@
         <p:spPr>
           <a:xfrm>
             <a:off x="4535280" y="2505600"/>
-            <a:ext cx="2871000" cy="310680"/>
+            <a:ext cx="2870640" cy="310320"/>
           </a:xfrm>
           <a:prstGeom prst="rect">
             <a:avLst/>
@@ -16998,7 +17062,7 @@
         <p:spPr>
           <a:xfrm>
             <a:off x="5422320" y="3173040"/>
-            <a:ext cx="1096920" cy="1096920"/>
+            <a:ext cx="1096560" cy="1096560"/>
           </a:xfrm>
           <a:prstGeom prst="arc">
             <a:avLst>
@@ -17050,7 +17114,7 @@
         <p:spPr>
           <a:xfrm>
             <a:off x="5422320" y="3173040"/>
-            <a:ext cx="1096920" cy="1096920"/>
+            <a:ext cx="1096560" cy="1096560"/>
           </a:xfrm>
           <a:prstGeom prst="arc">
             <a:avLst>
@@ -17102,7 +17166,7 @@
         <p:spPr>
           <a:xfrm>
             <a:off x="5422320" y="3173040"/>
-            <a:ext cx="1096920" cy="1096920"/>
+            <a:ext cx="1096560" cy="1096560"/>
           </a:xfrm>
           <a:prstGeom prst="arc">
             <a:avLst>
@@ -17154,7 +17218,7 @@
         <p:spPr>
           <a:xfrm>
             <a:off x="5422320" y="3173040"/>
-            <a:ext cx="1096920" cy="1096920"/>
+            <a:ext cx="1096560" cy="1096560"/>
           </a:xfrm>
           <a:prstGeom prst="arc">
             <a:avLst>
@@ -17206,7 +17270,7 @@
         <p:spPr>
           <a:xfrm>
             <a:off x="5513760" y="3566160"/>
-            <a:ext cx="914040" cy="310680"/>
+            <a:ext cx="913680" cy="310320"/>
           </a:xfrm>
           <a:prstGeom prst="rect">
             <a:avLst/>
@@ -17260,7 +17324,7 @@
         <p:spPr>
           <a:xfrm>
             <a:off x="5577840" y="2880360"/>
-            <a:ext cx="785880" cy="219240"/>
+            <a:ext cx="785520" cy="218880"/>
           </a:xfrm>
           <a:prstGeom prst="roundRect">
             <a:avLst>
@@ -17318,7 +17382,7 @@
         <p:spPr>
           <a:xfrm>
             <a:off x="6602040" y="3611880"/>
-            <a:ext cx="785880" cy="219240"/>
+            <a:ext cx="785520" cy="218880"/>
           </a:xfrm>
           <a:prstGeom prst="roundRect">
             <a:avLst>
@@ -17376,7 +17440,7 @@
         <p:spPr>
           <a:xfrm>
             <a:off x="5719680" y="4343400"/>
-            <a:ext cx="502560" cy="219240"/>
+            <a:ext cx="502200" cy="218880"/>
           </a:xfrm>
           <a:prstGeom prst="roundRect">
             <a:avLst>
@@ -17434,7 +17498,7 @@
         <p:spPr>
           <a:xfrm>
             <a:off x="4553640" y="3611880"/>
-            <a:ext cx="785880" cy="219240"/>
+            <a:ext cx="785520" cy="218880"/>
           </a:xfrm>
           <a:prstGeom prst="roundRect">
             <a:avLst>
@@ -17492,7 +17556,7 @@
         <p:spPr>
           <a:xfrm>
             <a:off x="4507920" y="4663440"/>
-            <a:ext cx="2925720" cy="219240"/>
+            <a:ext cx="2925360" cy="218880"/>
           </a:xfrm>
           <a:prstGeom prst="rect">
             <a:avLst/>
@@ -17546,7 +17610,7 @@
         <p:spPr>
           <a:xfrm>
             <a:off x="1098360" y="6510600"/>
-            <a:ext cx="2503080" cy="104040"/>
+            <a:ext cx="2502720" cy="103680"/>
           </a:xfrm>
           <a:prstGeom prst="rect">
             <a:avLst/>
@@ -17664,7 +17728,7 @@
         <p:spPr>
           <a:xfrm>
             <a:off x="567000" y="164520"/>
-            <a:ext cx="3382920" cy="129960"/>
+            <a:ext cx="3382560" cy="129600"/>
           </a:xfrm>
           <a:prstGeom prst="rect">
             <a:avLst/>
@@ -17718,7 +17782,7 @@
         <p:spPr>
           <a:xfrm>
             <a:off x="10716840" y="164520"/>
-            <a:ext cx="685440" cy="129960"/>
+            <a:ext cx="685080" cy="129600"/>
           </a:xfrm>
           <a:prstGeom prst="rect">
             <a:avLst/>
@@ -17772,7 +17836,7 @@
         <p:spPr>
           <a:xfrm>
             <a:off x="567000" y="457200"/>
-            <a:ext cx="10835280" cy="10440"/>
+            <a:ext cx="10834920" cy="10080"/>
           </a:xfrm>
           <a:prstGeom prst="rect">
             <a:avLst/>
@@ -17828,7 +17892,7 @@
         <p:spPr>
           <a:xfrm>
             <a:off x="567000" y="640080"/>
-            <a:ext cx="10515240" cy="358560"/>
+            <a:ext cx="10514880" cy="358200"/>
           </a:xfrm>
           <a:prstGeom prst="rect">
             <a:avLst/>
@@ -17884,7 +17948,7 @@
         <p:spPr>
           <a:xfrm>
             <a:off x="567000" y="1078920"/>
-            <a:ext cx="10515240" cy="341640"/>
+            <a:ext cx="10514880" cy="341280"/>
           </a:xfrm>
           <a:prstGeom prst="rect">
             <a:avLst/>
@@ -17938,7 +18002,7 @@
         <p:spPr>
           <a:xfrm>
             <a:off x="567000" y="1664280"/>
-            <a:ext cx="6537600" cy="3401280"/>
+            <a:ext cx="6537240" cy="3400920"/>
           </a:xfrm>
           <a:prstGeom prst="roundRect">
             <a:avLst>
@@ -17996,7 +18060,7 @@
         <p:spPr>
           <a:xfrm>
             <a:off x="567000" y="1664280"/>
-            <a:ext cx="50040" cy="3401280"/>
+            <a:ext cx="49680" cy="3400920"/>
           </a:xfrm>
           <a:prstGeom prst="rect">
             <a:avLst/>
@@ -18052,7 +18116,7 @@
         <p:spPr>
           <a:xfrm>
             <a:off x="731520" y="1810440"/>
-            <a:ext cx="6208560" cy="198720"/>
+            <a:ext cx="6208200" cy="198360"/>
           </a:xfrm>
           <a:prstGeom prst="rect">
             <a:avLst/>
@@ -18106,7 +18170,7 @@
         <p:spPr>
           <a:xfrm>
             <a:off x="731520" y="2139840"/>
-            <a:ext cx="6208560" cy="1221480"/>
+            <a:ext cx="6208200" cy="1221120"/>
           </a:xfrm>
           <a:prstGeom prst="rect">
             <a:avLst/>
@@ -18192,7 +18256,7 @@
         <p:spPr>
           <a:xfrm>
             <a:off x="841320" y="4187880"/>
-            <a:ext cx="1663920" cy="566640"/>
+            <a:ext cx="1663560" cy="566280"/>
           </a:xfrm>
           <a:prstGeom prst="roundRect">
             <a:avLst>
@@ -18250,7 +18314,7 @@
         <p:spPr>
           <a:xfrm>
             <a:off x="914400" y="4270320"/>
-            <a:ext cx="1517400" cy="243720"/>
+            <a:ext cx="1517040" cy="243360"/>
           </a:xfrm>
           <a:prstGeom prst="rect">
             <a:avLst/>
@@ -18317,7 +18381,7 @@
         <p:spPr>
           <a:xfrm>
             <a:off x="914400" y="4553640"/>
-            <a:ext cx="1517400" cy="111960"/>
+            <a:ext cx="1517040" cy="111600"/>
           </a:xfrm>
           <a:prstGeom prst="rect">
             <a:avLst/>
@@ -18371,7 +18435,7 @@
         <p:spPr>
           <a:xfrm>
             <a:off x="2541960" y="4389120"/>
-            <a:ext cx="228240" cy="167400"/>
+            <a:ext cx="227880" cy="167400"/>
           </a:xfrm>
           <a:prstGeom prst="rect">
             <a:avLst/>
@@ -18425,7 +18489,7 @@
         <p:spPr>
           <a:xfrm>
             <a:off x="2834640" y="4187880"/>
-            <a:ext cx="1663920" cy="566640"/>
+            <a:ext cx="1663560" cy="566280"/>
           </a:xfrm>
           <a:prstGeom prst="roundRect">
             <a:avLst>
@@ -18483,7 +18547,7 @@
         <p:spPr>
           <a:xfrm>
             <a:off x="2907720" y="4270320"/>
-            <a:ext cx="1517400" cy="243720"/>
+            <a:ext cx="1517040" cy="243360"/>
           </a:xfrm>
           <a:prstGeom prst="rect">
             <a:avLst/>
@@ -18550,7 +18614,7 @@
         <p:spPr>
           <a:xfrm>
             <a:off x="2907720" y="4553640"/>
-            <a:ext cx="1517400" cy="111960"/>
+            <a:ext cx="1517040" cy="111600"/>
           </a:xfrm>
           <a:prstGeom prst="rect">
             <a:avLst/>
@@ -18604,7 +18668,7 @@
         <p:spPr>
           <a:xfrm>
             <a:off x="4535280" y="4389120"/>
-            <a:ext cx="228240" cy="167400"/>
+            <a:ext cx="227880" cy="167400"/>
           </a:xfrm>
           <a:prstGeom prst="rect">
             <a:avLst/>
@@ -18658,7 +18722,7 @@
         <p:spPr>
           <a:xfrm>
             <a:off x="4827960" y="4187880"/>
-            <a:ext cx="1663920" cy="566640"/>
+            <a:ext cx="1663560" cy="566280"/>
           </a:xfrm>
           <a:prstGeom prst="roundRect">
             <a:avLst>
@@ -18716,7 +18780,7 @@
         <p:spPr>
           <a:xfrm>
             <a:off x="4901040" y="4270320"/>
-            <a:ext cx="1517400" cy="243720"/>
+            <a:ext cx="1517040" cy="243360"/>
           </a:xfrm>
           <a:prstGeom prst="rect">
             <a:avLst/>
@@ -18783,7 +18847,7 @@
         <p:spPr>
           <a:xfrm>
             <a:off x="4901040" y="4553640"/>
-            <a:ext cx="1517400" cy="111960"/>
+            <a:ext cx="1517040" cy="111600"/>
           </a:xfrm>
           <a:prstGeom prst="rect">
             <a:avLst/>
@@ -18837,7 +18901,7 @@
         <p:spPr>
           <a:xfrm>
             <a:off x="7333560" y="1664280"/>
-            <a:ext cx="4068720" cy="3401280"/>
+            <a:ext cx="4068360" cy="3400920"/>
           </a:xfrm>
           <a:prstGeom prst="roundRect">
             <a:avLst>
@@ -18895,7 +18959,7 @@
         <p:spPr>
           <a:xfrm>
             <a:off x="7333560" y="1664280"/>
-            <a:ext cx="50040" cy="3401280"/>
+            <a:ext cx="49680" cy="3400920"/>
           </a:xfrm>
           <a:prstGeom prst="rect">
             <a:avLst/>
@@ -18951,7 +19015,7 @@
         <p:spPr>
           <a:xfrm>
             <a:off x="7498080" y="1810440"/>
-            <a:ext cx="3739680" cy="198720"/>
+            <a:ext cx="3739320" cy="198360"/>
           </a:xfrm>
           <a:prstGeom prst="rect">
             <a:avLst/>
@@ -19005,7 +19069,7 @@
         <p:spPr>
           <a:xfrm>
             <a:off x="7498080" y="2139840"/>
-            <a:ext cx="3739680" cy="1832040"/>
+            <a:ext cx="3739320" cy="1831680"/>
           </a:xfrm>
           <a:prstGeom prst="rect">
             <a:avLst/>
@@ -19117,7 +19181,7 @@
         <p:spPr>
           <a:xfrm>
             <a:off x="567000" y="5321880"/>
-            <a:ext cx="2742840" cy="125280"/>
+            <a:ext cx="2742480" cy="124920"/>
           </a:xfrm>
           <a:prstGeom prst="rect">
             <a:avLst/>
@@ -19171,7 +19235,7 @@
         <p:spPr>
           <a:xfrm>
             <a:off x="567000" y="5559480"/>
-            <a:ext cx="3382920" cy="420120"/>
+            <a:ext cx="3382560" cy="419760"/>
           </a:xfrm>
           <a:prstGeom prst="roundRect">
             <a:avLst>
@@ -19229,7 +19293,7 @@
         <p:spPr>
           <a:xfrm>
             <a:off x="621720" y="5721840"/>
-            <a:ext cx="3273120" cy="131760"/>
+            <a:ext cx="3272760" cy="131400"/>
           </a:xfrm>
           <a:prstGeom prst="rect">
             <a:avLst/>
@@ -19285,7 +19349,7 @@
         <p:spPr>
           <a:xfrm>
             <a:off x="4407480" y="5559480"/>
-            <a:ext cx="3382920" cy="420120"/>
+            <a:ext cx="3382560" cy="419760"/>
           </a:xfrm>
           <a:prstGeom prst="roundRect">
             <a:avLst>
@@ -19343,7 +19407,7 @@
         <p:spPr>
           <a:xfrm>
             <a:off x="4462200" y="5721840"/>
-            <a:ext cx="3273120" cy="131760"/>
+            <a:ext cx="3272760" cy="131400"/>
           </a:xfrm>
           <a:prstGeom prst="rect">
             <a:avLst/>
@@ -19399,7 +19463,7 @@
         <p:spPr>
           <a:xfrm>
             <a:off x="8247960" y="5559480"/>
-            <a:ext cx="3154320" cy="420120"/>
+            <a:ext cx="3153960" cy="419760"/>
           </a:xfrm>
           <a:prstGeom prst="roundRect">
             <a:avLst>
@@ -19457,7 +19521,7 @@
         <p:spPr>
           <a:xfrm>
             <a:off x="8302680" y="5721840"/>
-            <a:ext cx="3044520" cy="131760"/>
+            <a:ext cx="3044160" cy="131400"/>
           </a:xfrm>
           <a:prstGeom prst="rect">
             <a:avLst/>
@@ -19513,7 +19577,7 @@
         <p:spPr>
           <a:xfrm>
             <a:off x="567000" y="6236280"/>
-            <a:ext cx="10835280" cy="10440"/>
+            <a:ext cx="10834920" cy="10080"/>
           </a:xfrm>
           <a:prstGeom prst="rect">
             <a:avLst/>
@@ -19569,7 +19633,7 @@
         <p:spPr>
           <a:xfrm>
             <a:off x="3931920" y="6355080"/>
-            <a:ext cx="3931560" cy="110160"/>
+            <a:ext cx="3931200" cy="109800"/>
           </a:xfrm>
           <a:prstGeom prst="rect">
             <a:avLst/>
@@ -19623,7 +19687,7 @@
         <p:spPr>
           <a:xfrm>
             <a:off x="11045880" y="6355080"/>
-            <a:ext cx="273960" cy="129960"/>
+            <a:ext cx="273600" cy="129600"/>
           </a:xfrm>
           <a:prstGeom prst="rect">
             <a:avLst/>
@@ -19677,7 +19741,7 @@
         <p:spPr>
           <a:xfrm>
             <a:off x="1444680" y="6510600"/>
-            <a:ext cx="1810080" cy="104040"/>
+            <a:ext cx="1809720" cy="103680"/>
           </a:xfrm>
           <a:prstGeom prst="rect">
             <a:avLst/>
@@ -19773,7 +19837,7 @@
         <p:spPr>
           <a:xfrm>
             <a:off x="585360" y="155520"/>
-            <a:ext cx="3200040" cy="220680"/>
+            <a:ext cx="3199680" cy="220680"/>
           </a:xfrm>
           <a:prstGeom prst="rect">
             <a:avLst/>
@@ -19827,7 +19891,7 @@
         <p:spPr>
           <a:xfrm>
             <a:off x="10561320" y="155520"/>
-            <a:ext cx="685440" cy="220680"/>
+            <a:ext cx="685080" cy="220680"/>
           </a:xfrm>
           <a:prstGeom prst="rect">
             <a:avLst/>
@@ -19881,7 +19945,7 @@
         <p:spPr>
           <a:xfrm>
             <a:off x="585360" y="457200"/>
-            <a:ext cx="10826280" cy="10440"/>
+            <a:ext cx="10825920" cy="10080"/>
           </a:xfrm>
           <a:prstGeom prst="rect">
             <a:avLst/>
@@ -19934,7 +19998,7 @@
         <p:spPr>
           <a:xfrm>
             <a:off x="585360" y="511920"/>
-            <a:ext cx="10826280" cy="5040"/>
+            <a:ext cx="10825920" cy="4680"/>
           </a:xfrm>
           <a:prstGeom prst="rect">
             <a:avLst/>
@@ -19987,7 +20051,7 @@
         <p:spPr>
           <a:xfrm>
             <a:off x="621720" y="694800"/>
-            <a:ext cx="10606680" cy="447840"/>
+            <a:ext cx="10606320" cy="447840"/>
           </a:xfrm>
           <a:prstGeom prst="rect">
             <a:avLst/>
@@ -20041,7 +20105,7 @@
         <p:spPr>
           <a:xfrm>
             <a:off x="621720" y="1152000"/>
-            <a:ext cx="10515240" cy="252360"/>
+            <a:ext cx="10514880" cy="252360"/>
           </a:xfrm>
           <a:prstGeom prst="rect">
             <a:avLst/>
@@ -20095,7 +20159,7 @@
         <p:spPr>
           <a:xfrm>
             <a:off x="585360" y="6446520"/>
-            <a:ext cx="10826280" cy="10440"/>
+            <a:ext cx="10825920" cy="10080"/>
           </a:xfrm>
           <a:prstGeom prst="rect">
             <a:avLst/>
@@ -20148,7 +20212,7 @@
         <p:spPr>
           <a:xfrm>
             <a:off x="567000" y="6510600"/>
-            <a:ext cx="5211720" cy="207000"/>
+            <a:ext cx="5211360" cy="207000"/>
           </a:xfrm>
           <a:prstGeom prst="rect">
             <a:avLst/>
@@ -20202,7 +20266,7 @@
         <p:spPr>
           <a:xfrm>
             <a:off x="4343400" y="6510600"/>
-            <a:ext cx="3657240" cy="205560"/>
+            <a:ext cx="3656880" cy="205560"/>
           </a:xfrm>
           <a:prstGeom prst="rect">
             <a:avLst/>
@@ -20256,7 +20320,7 @@
         <p:spPr>
           <a:xfrm>
             <a:off x="11018520" y="6510600"/>
-            <a:ext cx="228240" cy="219240"/>
+            <a:ext cx="227880" cy="219240"/>
           </a:xfrm>
           <a:prstGeom prst="rect">
             <a:avLst/>
@@ -20310,7 +20374,7 @@
         <p:spPr>
           <a:xfrm>
             <a:off x="621720" y="1664280"/>
-            <a:ext cx="3382920" cy="3181680"/>
+            <a:ext cx="3382560" cy="3181320"/>
           </a:xfrm>
           <a:prstGeom prst="roundRect">
             <a:avLst>
@@ -20368,7 +20432,7 @@
         <p:spPr>
           <a:xfrm>
             <a:off x="621720" y="1664280"/>
-            <a:ext cx="50040" cy="3181680"/>
+            <a:ext cx="49680" cy="3181320"/>
           </a:xfrm>
           <a:prstGeom prst="rect">
             <a:avLst/>
@@ -20421,7 +20485,7 @@
         <p:spPr>
           <a:xfrm>
             <a:off x="822960" y="1847160"/>
-            <a:ext cx="2971440" cy="232920"/>
+            <a:ext cx="2971080" cy="232920"/>
           </a:xfrm>
           <a:prstGeom prst="rect">
             <a:avLst/>
@@ -20475,7 +20539,7 @@
         <p:spPr>
           <a:xfrm>
             <a:off x="822960" y="2258640"/>
-            <a:ext cx="2971440" cy="1178280"/>
+            <a:ext cx="2971080" cy="1178280"/>
           </a:xfrm>
           <a:prstGeom prst="rect">
             <a:avLst/>
@@ -20604,7 +20668,7 @@
         <p:spPr>
           <a:xfrm>
             <a:off x="4160520" y="1664280"/>
-            <a:ext cx="3382920" cy="3181680"/>
+            <a:ext cx="3382560" cy="3181320"/>
           </a:xfrm>
           <a:prstGeom prst="roundRect">
             <a:avLst>
@@ -20662,7 +20726,7 @@
         <p:spPr>
           <a:xfrm>
             <a:off x="4160520" y="1664280"/>
-            <a:ext cx="50040" cy="3181680"/>
+            <a:ext cx="49680" cy="3181320"/>
           </a:xfrm>
           <a:prstGeom prst="rect">
             <a:avLst/>
@@ -20715,7 +20779,7 @@
         <p:spPr>
           <a:xfrm>
             <a:off x="4361760" y="1847160"/>
-            <a:ext cx="2971440" cy="232920"/>
+            <a:ext cx="2971080" cy="232920"/>
           </a:xfrm>
           <a:prstGeom prst="rect">
             <a:avLst/>
@@ -20769,7 +20833,7 @@
         <p:spPr>
           <a:xfrm>
             <a:off x="4361760" y="2258640"/>
-            <a:ext cx="2971440" cy="1178280"/>
+            <a:ext cx="2971080" cy="1178280"/>
           </a:xfrm>
           <a:prstGeom prst="rect">
             <a:avLst/>
@@ -20898,7 +20962,7 @@
         <p:spPr>
           <a:xfrm>
             <a:off x="7699320" y="1664280"/>
-            <a:ext cx="3584160" cy="3181680"/>
+            <a:ext cx="3583800" cy="3181320"/>
           </a:xfrm>
           <a:prstGeom prst="roundRect">
             <a:avLst>
@@ -20956,7 +21020,7 @@
         <p:spPr>
           <a:xfrm>
             <a:off x="7699320" y="1664280"/>
-            <a:ext cx="50040" cy="3181680"/>
+            <a:ext cx="49680" cy="3181320"/>
           </a:xfrm>
           <a:prstGeom prst="rect">
             <a:avLst/>
@@ -21009,7 +21073,7 @@
         <p:spPr>
           <a:xfrm>
             <a:off x="7900560" y="1847160"/>
-            <a:ext cx="3172680" cy="232920"/>
+            <a:ext cx="3172320" cy="232920"/>
           </a:xfrm>
           <a:prstGeom prst="rect">
             <a:avLst/>
@@ -21063,7 +21127,7 @@
         <p:spPr>
           <a:xfrm>
             <a:off x="7900560" y="2258640"/>
-            <a:ext cx="3172680" cy="1489320"/>
+            <a:ext cx="3172320" cy="1489320"/>
           </a:xfrm>
           <a:prstGeom prst="rect">
             <a:avLst/>
@@ -21192,7 +21256,7 @@
         <p:spPr>
           <a:xfrm>
             <a:off x="658440" y="5074920"/>
-            <a:ext cx="2102760" cy="231480"/>
+            <a:ext cx="2102400" cy="231480"/>
           </a:xfrm>
           <a:prstGeom prst="rect">
             <a:avLst/>
@@ -21246,7 +21310,7 @@
         <p:spPr>
           <a:xfrm>
             <a:off x="658440" y="5431680"/>
-            <a:ext cx="1965600" cy="502560"/>
+            <a:ext cx="1965240" cy="502200"/>
           </a:xfrm>
           <a:prstGeom prst="roundRect">
             <a:avLst>
@@ -21304,7 +21368,7 @@
         <p:spPr>
           <a:xfrm>
             <a:off x="731520" y="5543640"/>
-            <a:ext cx="1819440" cy="223200"/>
+            <a:ext cx="1819080" cy="223200"/>
           </a:xfrm>
           <a:prstGeom prst="rect">
             <a:avLst/>
@@ -21358,7 +21422,7 @@
         <p:spPr>
           <a:xfrm>
             <a:off x="2642760" y="5523120"/>
-            <a:ext cx="246600" cy="303120"/>
+            <a:ext cx="246240" cy="303120"/>
           </a:xfrm>
           <a:prstGeom prst="rect">
             <a:avLst/>
@@ -21412,7 +21476,7 @@
         <p:spPr>
           <a:xfrm>
             <a:off x="2935080" y="5431680"/>
-            <a:ext cx="2239920" cy="502560"/>
+            <a:ext cx="2239560" cy="502200"/>
           </a:xfrm>
           <a:prstGeom prst="roundRect">
             <a:avLst>
@@ -21470,7 +21534,7 @@
         <p:spPr>
           <a:xfrm>
             <a:off x="3008520" y="5477040"/>
-            <a:ext cx="2093760" cy="357120"/>
+            <a:ext cx="2093400" cy="357120"/>
           </a:xfrm>
           <a:prstGeom prst="rect">
             <a:avLst/>
@@ -21524,7 +21588,7 @@
         <p:spPr>
           <a:xfrm>
             <a:off x="5193720" y="5523120"/>
-            <a:ext cx="246600" cy="303120"/>
+            <a:ext cx="246240" cy="303120"/>
           </a:xfrm>
           <a:prstGeom prst="rect">
             <a:avLst/>
@@ -21578,7 +21642,7 @@
         <p:spPr>
           <a:xfrm>
             <a:off x="5486400" y="5431680"/>
-            <a:ext cx="1782720" cy="502560"/>
+            <a:ext cx="1782360" cy="502200"/>
           </a:xfrm>
           <a:prstGeom prst="roundRect">
             <a:avLst>
@@ -21636,7 +21700,7 @@
         <p:spPr>
           <a:xfrm>
             <a:off x="5559480" y="5543640"/>
-            <a:ext cx="1636560" cy="223200"/>
+            <a:ext cx="1636200" cy="223200"/>
           </a:xfrm>
           <a:prstGeom prst="rect">
             <a:avLst/>
@@ -21690,7 +21754,7 @@
         <p:spPr>
           <a:xfrm>
             <a:off x="7287840" y="5523120"/>
-            <a:ext cx="246600" cy="303120"/>
+            <a:ext cx="246240" cy="303120"/>
           </a:xfrm>
           <a:prstGeom prst="rect">
             <a:avLst/>
@@ -21744,7 +21808,7 @@
         <p:spPr>
           <a:xfrm>
             <a:off x="7580520" y="5431680"/>
-            <a:ext cx="2102760" cy="502560"/>
+            <a:ext cx="2102400" cy="502200"/>
           </a:xfrm>
           <a:prstGeom prst="roundRect">
             <a:avLst>
@@ -21802,7 +21866,7 @@
         <p:spPr>
           <a:xfrm>
             <a:off x="7653600" y="5477040"/>
-            <a:ext cx="1956600" cy="357120"/>
+            <a:ext cx="1956240" cy="357120"/>
           </a:xfrm>
           <a:prstGeom prst="rect">
             <a:avLst/>
@@ -21856,7 +21920,7 @@
         <p:spPr>
           <a:xfrm>
             <a:off x="9701640" y="5523120"/>
-            <a:ext cx="246600" cy="303120"/>
+            <a:ext cx="246240" cy="303120"/>
           </a:xfrm>
           <a:prstGeom prst="rect">
             <a:avLst/>
@@ -21910,7 +21974,7 @@
         <p:spPr>
           <a:xfrm>
             <a:off x="9994320" y="5431680"/>
-            <a:ext cx="2057040" cy="502560"/>
+            <a:ext cx="2056680" cy="502200"/>
           </a:xfrm>
           <a:prstGeom prst="roundRect">
             <a:avLst>
@@ -21968,7 +22032,7 @@
         <p:spPr>
           <a:xfrm>
             <a:off x="10067400" y="5543640"/>
-            <a:ext cx="1910880" cy="223200"/>
+            <a:ext cx="1910520" cy="223200"/>
           </a:xfrm>
           <a:prstGeom prst="rect">
             <a:avLst/>
@@ -22022,7 +22086,7 @@
         <p:spPr>
           <a:xfrm>
             <a:off x="667440" y="6126480"/>
-            <a:ext cx="10560960" cy="220680"/>
+            <a:ext cx="10560600" cy="220680"/>
           </a:xfrm>
           <a:prstGeom prst="rect">
             <a:avLst/>

</xml_diff>